<commit_message>
Add real app screenshots to report and presentation
Add the eight app screenshots (landing, sign-up, log-in, three create-persona
wizard steps, text chat, voice call). Report: replace the screenshots figure with
an 8-panel grid of the real screens, and reference the chat screen as live
evidence of temporal grounding (the legacy persona declines to invent a recent
event). Presentation: put the chat screenshot on the safety slide as proof, and
replace the app-slide placeholders with the real onboarding-to-voice flow.

Co-Authored-By: Claude Opus 4.8 <noreply@anthropic.com>
</commit_message>
<xml_diff>
--- a/backend/docs/report/NinaivX-Presentation.pptx
+++ b/backend/docs/report/NinaivX-Presentation.pptx
@@ -1285,7 +1285,7 @@
           <a:lstStyle/>
           <a:p>
             <a:r>
-              <a:t>Four safeguards. First, the air-gap — a guarantee in code, not a promise in a prompt. Second, temporal grounding: a persona who died in 2010 doesn't know about COVID or ChatGPT. Third, transparency: it never pretends to be truly human if you sincerely ask. And fourth, the supporting layer — content rules per mode, defence against prompt injection, and strict data isolation so no one can reach another user's persona.</a:t>
+              <a:t>Four safeguards. First, the air-gap — a guarantee in code, not a promise in a prompt. Second, temporal grounding: a persona who died in 2010 doesn't know about COVID or ChatGPT. Third, transparency: it never pretends to be truly human if you sincerely ask. And fourth, the supporting layer — content rules per mode, defence against prompt injection, and strict data isolation. Point at the screenshot on the right: this is real — a legacy persona asked about a recent flood says its knowledge stopped after a point and refuses to invent details. That's temporal grounding working in the app.</a:t>
             </a:r>
           </a:p>
         </p:txBody>
@@ -1355,7 +1355,7 @@
           <a:lstStyle/>
           <a:p>
             <a:r>
-              <a:t>This is the app — built with React Native and Expo, so it runs on a normal phone. I'll walk through it with these screenshots [replace the placeholders with your images]: you sign up, create a persona in a short wizard — giving its personality and picking or cloning a voice — then chat by text or tap into a voice call and actually hear it reply. If time allows I can show it live, but the screenshots cover the flow.</a:t>
+              <a:t>This is the app — built with React Native and Expo, so it runs on a normal phone. Walk left to right: you land here, sign up, then create a persona in a short three-step wizard — who they are, their story, and their voice, which you can pick or clone from a short recording — and finally you can talk to it and hear it reply in a voice call. Rather than a live demo, these screenshots show the whole flow end to end.</a:t>
             </a:r>
           </a:p>
         </p:txBody>
@@ -8376,8 +8376,8 @@
         </p:nvSpPr>
         <p:spPr>
           <a:xfrm>
-            <a:off x="594360" y="1508760"/>
-            <a:ext cx="10789920" cy="4572000"/>
+            <a:off x="594360" y="1554480"/>
+            <a:ext cx="7772400" cy="4572000"/>
           </a:xfrm>
           <a:prstGeom prst="rect">
             <a:avLst/>
@@ -8395,11 +8395,11 @@
                 <a:spcPts val="0"/>
               </a:spcBef>
               <a:spcAft>
-                <a:spcPts val="1300"/>
+                <a:spcPts val="1400"/>
               </a:spcAft>
             </a:pPr>
             <a:r>
-              <a:rPr sz="1900" b="1" i="0">
+              <a:rPr sz="1800" b="1" i="0">
                 <a:solidFill>
                   <a:srgbClr val="2A6F6B"/>
                 </a:solidFill>
@@ -8408,7 +8408,7 @@
               <a:t>▪  </a:t>
             </a:r>
             <a:r>
-              <a:rPr sz="1900" b="0" i="0">
+              <a:rPr sz="1800" b="0" i="0">
                 <a:solidFill>
                   <a:srgbClr val="444E57"/>
                 </a:solidFill>
@@ -8423,11 +8423,11 @@
                 <a:spcPts val="0"/>
               </a:spcBef>
               <a:spcAft>
-                <a:spcPts val="1300"/>
+                <a:spcPts val="1400"/>
               </a:spcAft>
             </a:pPr>
             <a:r>
-              <a:rPr sz="1900" b="1" i="0">
+              <a:rPr sz="1800" b="1" i="0">
                 <a:solidFill>
                   <a:srgbClr val="2A6F6B"/>
                 </a:solidFill>
@@ -8436,7 +8436,7 @@
               <a:t>▪  </a:t>
             </a:r>
             <a:r>
-              <a:rPr sz="1900" b="0" i="0">
+              <a:rPr sz="1800" b="0" i="0">
                 <a:solidFill>
                   <a:srgbClr val="444E57"/>
                 </a:solidFill>
@@ -8451,11 +8451,11 @@
                 <a:spcPts val="0"/>
               </a:spcBef>
               <a:spcAft>
-                <a:spcPts val="1300"/>
+                <a:spcPts val="1400"/>
               </a:spcAft>
             </a:pPr>
             <a:r>
-              <a:rPr sz="1900" b="1" i="0">
+              <a:rPr sz="1800" b="1" i="0">
                 <a:solidFill>
                   <a:srgbClr val="2A6F6B"/>
                 </a:solidFill>
@@ -8464,7 +8464,7 @@
               <a:t>▪  </a:t>
             </a:r>
             <a:r>
-              <a:rPr sz="1900" b="0" i="0">
+              <a:rPr sz="1800" b="0" i="0">
                 <a:solidFill>
                   <a:srgbClr val="444E57"/>
                 </a:solidFill>
@@ -8479,11 +8479,11 @@
                 <a:spcPts val="0"/>
               </a:spcBef>
               <a:spcAft>
-                <a:spcPts val="1300"/>
+                <a:spcPts val="1400"/>
               </a:spcAft>
             </a:pPr>
             <a:r>
-              <a:rPr sz="1900" b="1" i="0">
+              <a:rPr sz="1800" b="1" i="0">
                 <a:solidFill>
                   <a:srgbClr val="2A6F6B"/>
                 </a:solidFill>
@@ -8492,7 +8492,7 @@
               <a:t>▪  </a:t>
             </a:r>
             <a:r>
-              <a:rPr sz="1900" b="0" i="0">
+              <a:rPr sz="1800" b="0" i="0">
                 <a:solidFill>
                   <a:srgbClr val="444E57"/>
                 </a:solidFill>
@@ -8503,16 +8503,40 @@
           </a:p>
         </p:txBody>
       </p:sp>
-      <p:sp>
-        <p:nvSpPr>
-          <p:cNvPr id="6" name="TextBox 5"/>
+      <p:pic>
+        <p:nvPicPr>
+          <p:cNvPr id="6" name="Picture 5" descr="app-chat.png"/>
+          <p:cNvPicPr>
+            <a:picLocks noChangeAspect="1"/>
+          </p:cNvPicPr>
+          <p:nvPr/>
+        </p:nvPicPr>
+        <p:blipFill>
+          <a:blip r:embed="rId2"/>
+          <a:stretch>
+            <a:fillRect/>
+          </a:stretch>
+        </p:blipFill>
+        <p:spPr>
+          <a:xfrm>
+            <a:off x="9239201" y="1417320"/>
+            <a:ext cx="2004156" cy="4343400"/>
+          </a:xfrm>
+          <a:prstGeom prst="rect">
+            <a:avLst/>
+          </a:prstGeom>
+        </p:spPr>
+      </p:pic>
+      <p:sp>
+        <p:nvSpPr>
+          <p:cNvPr id="7" name="TextBox 6"/>
           <p:cNvSpPr txBox="1"/>
           <p:nvPr/>
         </p:nvSpPr>
         <p:spPr>
           <a:xfrm>
-            <a:off x="548640" y="6419088"/>
-            <a:ext cx="8229600" cy="320040"/>
+            <a:off x="8549640" y="5779008"/>
+            <a:ext cx="3383280" cy="365760"/>
           </a:xfrm>
           <a:prstGeom prst="rect">
             <a:avLst/>
@@ -8525,6 +8549,41 @@
           </a:bodyPr>
           <a:lstStyle/>
           <a:p>
+            <a:pPr algn="ctr"/>
+            <a:r>
+              <a:rPr sz="1050" b="0" i="1">
+                <a:solidFill>
+                  <a:srgbClr val="C97A1A"/>
+                </a:solidFill>
+                <a:latin typeface="Segoe UI"/>
+              </a:rPr>
+              <a:t>Temporal grounding in action — declines to invent a recent event</a:t>
+            </a:r>
+          </a:p>
+        </p:txBody>
+      </p:sp>
+      <p:sp>
+        <p:nvSpPr>
+          <p:cNvPr id="8" name="TextBox 7"/>
+          <p:cNvSpPr txBox="1"/>
+          <p:nvPr/>
+        </p:nvSpPr>
+        <p:spPr>
+          <a:xfrm>
+            <a:off x="548640" y="6419088"/>
+            <a:ext cx="8229600" cy="320040"/>
+          </a:xfrm>
+          <a:prstGeom prst="rect">
+            <a:avLst/>
+          </a:prstGeom>
+          <a:noFill/>
+        </p:spPr>
+        <p:txBody>
+          <a:bodyPr wrap="square" anchor="t" lIns="0" rIns="0" tIns="0" bIns="0">
+            <a:spAutoFit/>
+          </a:bodyPr>
+          <a:lstStyle/>
+          <a:p>
             <a:pPr algn="l"/>
             <a:r>
               <a:rPr sz="900" b="0" i="0">
@@ -8540,7 +8599,7 @@
       </p:sp>
       <p:sp>
         <p:nvSpPr>
-          <p:cNvPr id="7" name="TextBox 6"/>
+          <p:cNvPr id="9" name="TextBox 8"/>
           <p:cNvSpPr txBox="1"/>
           <p:nvPr/>
         </p:nvSpPr>
@@ -8749,53 +8808,30 @@
           </a:p>
         </p:txBody>
       </p:sp>
-      <p:sp>
-        <p:nvSpPr>
-          <p:cNvPr id="6" name="Rounded Rectangle 5"/>
-          <p:cNvSpPr/>
-          <p:nvPr/>
-        </p:nvSpPr>
-        <p:spPr>
-          <a:xfrm>
-            <a:off x="777240" y="2194560"/>
-            <a:ext cx="2468880" cy="3291840"/>
-          </a:xfrm>
-          <a:prstGeom prst="roundRect">
-            <a:avLst/>
-          </a:prstGeom>
-          <a:solidFill>
-            <a:srgbClr val="F6F8F9"/>
-          </a:solidFill>
-          <a:ln w="19050">
-            <a:solidFill>
-              <a:srgbClr val="8A97A5"/>
-            </a:solidFill>
-            <a:prstDash val="dash"/>
-          </a:ln>
-          <a:effectLst/>
-        </p:spPr>
-        <p:style>
-          <a:lnRef idx="1">
-            <a:schemeClr val="accent1"/>
-          </a:lnRef>
-          <a:fillRef idx="3">
-            <a:schemeClr val="accent1"/>
-          </a:fillRef>
-          <a:effectRef idx="2">
-            <a:schemeClr val="accent1"/>
-          </a:effectRef>
-          <a:fontRef idx="minor">
-            <a:schemeClr val="lt1"/>
-          </a:fontRef>
-        </p:style>
-        <p:txBody>
-          <a:bodyPr rtlCol="0" anchor="ctr"/>
-          <a:lstStyle/>
-          <a:p>
-            <a:pPr algn="ctr"/>
-          </a:p>
-        </p:txBody>
-      </p:sp>
+      <p:pic>
+        <p:nvPicPr>
+          <p:cNvPr id="6" name="Picture 5" descr="app-landing.png"/>
+          <p:cNvPicPr>
+            <a:picLocks noChangeAspect="1"/>
+          </p:cNvPicPr>
+          <p:nvPr/>
+        </p:nvPicPr>
+        <p:blipFill>
+          <a:blip r:embed="rId2"/>
+          <a:stretch>
+            <a:fillRect/>
+          </a:stretch>
+        </p:blipFill>
+        <p:spPr>
+          <a:xfrm>
+            <a:off x="472287" y="1595119"/>
+            <a:ext cx="1920240" cy="4161536"/>
+          </a:xfrm>
+          <a:prstGeom prst="rect">
+            <a:avLst/>
+          </a:prstGeom>
+        </p:spPr>
+      </p:pic>
       <p:sp>
         <p:nvSpPr>
           <p:cNvPr id="7" name="TextBox 6"/>
@@ -8804,337 +8840,8 @@
         </p:nvSpPr>
         <p:spPr>
           <a:xfrm>
-            <a:off x="868680" y="2194560"/>
-            <a:ext cx="2286000" cy="3291840"/>
-          </a:xfrm>
-          <a:prstGeom prst="rect">
-            <a:avLst/>
-          </a:prstGeom>
-          <a:noFill/>
-        </p:spPr>
-        <p:txBody>
-          <a:bodyPr wrap="square" anchor="ctr" lIns="0" rIns="0" tIns="0" bIns="0">
-            <a:spAutoFit/>
-          </a:bodyPr>
-          <a:lstStyle/>
-          <a:p>
-            <a:pPr algn="ctr"/>
-            <a:r>
-              <a:rPr sz="1200" b="0" i="1">
-                <a:solidFill>
-                  <a:srgbClr val="8A97A5"/>
-                </a:solidFill>
-                <a:latin typeface="Segoe UI"/>
-              </a:rPr>
-              <a:t>[ screenshot ]</a:t>
-            </a:r>
-          </a:p>
-          <a:p>
-            <a:pPr algn="ctr"/>
-            <a:r>
-              <a:rPr sz="1300" b="1" i="0">
-                <a:solidFill>
-                  <a:srgbClr val="444E57"/>
-                </a:solidFill>
-                <a:latin typeface="Segoe UI"/>
-              </a:rPr>
-              <a:t>Sign-up / log-in</a:t>
-            </a:r>
-          </a:p>
-        </p:txBody>
-      </p:sp>
-      <p:sp>
-        <p:nvSpPr>
-          <p:cNvPr id="8" name="Rounded Rectangle 7"/>
-          <p:cNvSpPr/>
-          <p:nvPr/>
-        </p:nvSpPr>
-        <p:spPr>
-          <a:xfrm>
-            <a:off x="3429000" y="2194560"/>
-            <a:ext cx="2468880" cy="3291840"/>
-          </a:xfrm>
-          <a:prstGeom prst="roundRect">
-            <a:avLst/>
-          </a:prstGeom>
-          <a:solidFill>
-            <a:srgbClr val="F6F8F9"/>
-          </a:solidFill>
-          <a:ln w="19050">
-            <a:solidFill>
-              <a:srgbClr val="8A97A5"/>
-            </a:solidFill>
-            <a:prstDash val="dash"/>
-          </a:ln>
-          <a:effectLst/>
-        </p:spPr>
-        <p:style>
-          <a:lnRef idx="1">
-            <a:schemeClr val="accent1"/>
-          </a:lnRef>
-          <a:fillRef idx="3">
-            <a:schemeClr val="accent1"/>
-          </a:fillRef>
-          <a:effectRef idx="2">
-            <a:schemeClr val="accent1"/>
-          </a:effectRef>
-          <a:fontRef idx="minor">
-            <a:schemeClr val="lt1"/>
-          </a:fontRef>
-        </p:style>
-        <p:txBody>
-          <a:bodyPr rtlCol="0" anchor="ctr"/>
-          <a:lstStyle/>
-          <a:p>
-            <a:pPr algn="ctr"/>
-          </a:p>
-        </p:txBody>
-      </p:sp>
-      <p:sp>
-        <p:nvSpPr>
-          <p:cNvPr id="9" name="TextBox 8"/>
-          <p:cNvSpPr txBox="1"/>
-          <p:nvPr/>
-        </p:nvSpPr>
-        <p:spPr>
-          <a:xfrm>
-            <a:off x="3520440" y="2194560"/>
-            <a:ext cx="2286000" cy="3291840"/>
-          </a:xfrm>
-          <a:prstGeom prst="rect">
-            <a:avLst/>
-          </a:prstGeom>
-          <a:noFill/>
-        </p:spPr>
-        <p:txBody>
-          <a:bodyPr wrap="square" anchor="ctr" lIns="0" rIns="0" tIns="0" bIns="0">
-            <a:spAutoFit/>
-          </a:bodyPr>
-          <a:lstStyle/>
-          <a:p>
-            <a:pPr algn="ctr"/>
-            <a:r>
-              <a:rPr sz="1200" b="0" i="1">
-                <a:solidFill>
-                  <a:srgbClr val="8A97A5"/>
-                </a:solidFill>
-                <a:latin typeface="Segoe UI"/>
-              </a:rPr>
-              <a:t>[ screenshot ]</a:t>
-            </a:r>
-          </a:p>
-          <a:p>
-            <a:pPr algn="ctr"/>
-            <a:r>
-              <a:rPr sz="1300" b="1" i="0">
-                <a:solidFill>
-                  <a:srgbClr val="444E57"/>
-                </a:solidFill>
-                <a:latin typeface="Segoe UI"/>
-              </a:rPr>
-              <a:t>Create-persona wizard</a:t>
-            </a:r>
-          </a:p>
-        </p:txBody>
-      </p:sp>
-      <p:sp>
-        <p:nvSpPr>
-          <p:cNvPr id="10" name="Rounded Rectangle 9"/>
-          <p:cNvSpPr/>
-          <p:nvPr/>
-        </p:nvSpPr>
-        <p:spPr>
-          <a:xfrm>
-            <a:off x="6355080" y="2194560"/>
-            <a:ext cx="2468880" cy="3291840"/>
-          </a:xfrm>
-          <a:prstGeom prst="roundRect">
-            <a:avLst/>
-          </a:prstGeom>
-          <a:solidFill>
-            <a:srgbClr val="F6F8F9"/>
-          </a:solidFill>
-          <a:ln w="19050">
-            <a:solidFill>
-              <a:srgbClr val="8A97A5"/>
-            </a:solidFill>
-            <a:prstDash val="dash"/>
-          </a:ln>
-          <a:effectLst/>
-        </p:spPr>
-        <p:style>
-          <a:lnRef idx="1">
-            <a:schemeClr val="accent1"/>
-          </a:lnRef>
-          <a:fillRef idx="3">
-            <a:schemeClr val="accent1"/>
-          </a:fillRef>
-          <a:effectRef idx="2">
-            <a:schemeClr val="accent1"/>
-          </a:effectRef>
-          <a:fontRef idx="minor">
-            <a:schemeClr val="lt1"/>
-          </a:fontRef>
-        </p:style>
-        <p:txBody>
-          <a:bodyPr rtlCol="0" anchor="ctr"/>
-          <a:lstStyle/>
-          <a:p>
-            <a:pPr algn="ctr"/>
-          </a:p>
-        </p:txBody>
-      </p:sp>
-      <p:sp>
-        <p:nvSpPr>
-          <p:cNvPr id="11" name="TextBox 10"/>
-          <p:cNvSpPr txBox="1"/>
-          <p:nvPr/>
-        </p:nvSpPr>
-        <p:spPr>
-          <a:xfrm>
-            <a:off x="6446520" y="2194560"/>
-            <a:ext cx="2286000" cy="3291840"/>
-          </a:xfrm>
-          <a:prstGeom prst="rect">
-            <a:avLst/>
-          </a:prstGeom>
-          <a:noFill/>
-        </p:spPr>
-        <p:txBody>
-          <a:bodyPr wrap="square" anchor="ctr" lIns="0" rIns="0" tIns="0" bIns="0">
-            <a:spAutoFit/>
-          </a:bodyPr>
-          <a:lstStyle/>
-          <a:p>
-            <a:pPr algn="ctr"/>
-            <a:r>
-              <a:rPr sz="1200" b="0" i="1">
-                <a:solidFill>
-                  <a:srgbClr val="8A97A5"/>
-                </a:solidFill>
-                <a:latin typeface="Segoe UI"/>
-              </a:rPr>
-              <a:t>[ screenshot ]</a:t>
-            </a:r>
-          </a:p>
-          <a:p>
-            <a:pPr algn="ctr"/>
-            <a:r>
-              <a:rPr sz="1300" b="1" i="0">
-                <a:solidFill>
-                  <a:srgbClr val="444E57"/>
-                </a:solidFill>
-                <a:latin typeface="Segoe UI"/>
-              </a:rPr>
-              <a:t>Text chat</a:t>
-            </a:r>
-          </a:p>
-        </p:txBody>
-      </p:sp>
-      <p:sp>
-        <p:nvSpPr>
-          <p:cNvPr id="12" name="Rounded Rectangle 11"/>
-          <p:cNvSpPr/>
-          <p:nvPr/>
-        </p:nvSpPr>
-        <p:spPr>
-          <a:xfrm>
-            <a:off x="9006840" y="2194560"/>
-            <a:ext cx="2468880" cy="3291840"/>
-          </a:xfrm>
-          <a:prstGeom prst="roundRect">
-            <a:avLst/>
-          </a:prstGeom>
-          <a:solidFill>
-            <a:srgbClr val="F6F8F9"/>
-          </a:solidFill>
-          <a:ln w="19050">
-            <a:solidFill>
-              <a:srgbClr val="8A97A5"/>
-            </a:solidFill>
-            <a:prstDash val="dash"/>
-          </a:ln>
-          <a:effectLst/>
-        </p:spPr>
-        <p:style>
-          <a:lnRef idx="1">
-            <a:schemeClr val="accent1"/>
-          </a:lnRef>
-          <a:fillRef idx="3">
-            <a:schemeClr val="accent1"/>
-          </a:fillRef>
-          <a:effectRef idx="2">
-            <a:schemeClr val="accent1"/>
-          </a:effectRef>
-          <a:fontRef idx="minor">
-            <a:schemeClr val="lt1"/>
-          </a:fontRef>
-        </p:style>
-        <p:txBody>
-          <a:bodyPr rtlCol="0" anchor="ctr"/>
-          <a:lstStyle/>
-          <a:p>
-            <a:pPr algn="ctr"/>
-          </a:p>
-        </p:txBody>
-      </p:sp>
-      <p:sp>
-        <p:nvSpPr>
-          <p:cNvPr id="13" name="TextBox 12"/>
-          <p:cNvSpPr txBox="1"/>
-          <p:nvPr/>
-        </p:nvSpPr>
-        <p:spPr>
-          <a:xfrm>
-            <a:off x="9098280" y="2194560"/>
-            <a:ext cx="2286000" cy="3291840"/>
-          </a:xfrm>
-          <a:prstGeom prst="rect">
-            <a:avLst/>
-          </a:prstGeom>
-          <a:noFill/>
-        </p:spPr>
-        <p:txBody>
-          <a:bodyPr wrap="square" anchor="ctr" lIns="0" rIns="0" tIns="0" bIns="0">
-            <a:spAutoFit/>
-          </a:bodyPr>
-          <a:lstStyle/>
-          <a:p>
-            <a:pPr algn="ctr"/>
-            <a:r>
-              <a:rPr sz="1200" b="0" i="1">
-                <a:solidFill>
-                  <a:srgbClr val="8A97A5"/>
-                </a:solidFill>
-                <a:latin typeface="Segoe UI"/>
-              </a:rPr>
-              <a:t>[ screenshot ]</a:t>
-            </a:r>
-          </a:p>
-          <a:p>
-            <a:pPr algn="ctr"/>
-            <a:r>
-              <a:rPr sz="1300" b="1" i="0">
-                <a:solidFill>
-                  <a:srgbClr val="444E57"/>
-                </a:solidFill>
-                <a:latin typeface="Segoe UI"/>
-              </a:rPr>
-              <a:t>Voice call</a:t>
-            </a:r>
-          </a:p>
-        </p:txBody>
-      </p:sp>
-      <p:sp>
-        <p:nvSpPr>
-          <p:cNvPr id="14" name="TextBox 13"/>
-          <p:cNvSpPr txBox="1"/>
-          <p:nvPr/>
-        </p:nvSpPr>
-        <p:spPr>
-          <a:xfrm>
-            <a:off x="548640" y="6419088"/>
-            <a:ext cx="8229600" cy="320040"/>
+            <a:off x="472287" y="5870448"/>
+            <a:ext cx="1920240" cy="320040"/>
           </a:xfrm>
           <a:prstGeom prst="rect">
             <a:avLst/>
@@ -9147,6 +8854,277 @@
           </a:bodyPr>
           <a:lstStyle/>
           <a:p>
+            <a:pPr algn="ctr"/>
+            <a:r>
+              <a:rPr sz="1200" b="1" i="0">
+                <a:solidFill>
+                  <a:srgbClr val="444E57"/>
+                </a:solidFill>
+                <a:latin typeface="Segoe UI"/>
+              </a:rPr>
+              <a:t>Landing</a:t>
+            </a:r>
+          </a:p>
+        </p:txBody>
+      </p:sp>
+      <p:pic>
+        <p:nvPicPr>
+          <p:cNvPr id="8" name="Picture 7" descr="app-signup.png"/>
+          <p:cNvPicPr>
+            <a:picLocks noChangeAspect="1"/>
+          </p:cNvPicPr>
+          <p:nvPr/>
+        </p:nvPicPr>
+        <p:blipFill>
+          <a:blip r:embed="rId3"/>
+          <a:stretch>
+            <a:fillRect/>
+          </a:stretch>
+        </p:blipFill>
+        <p:spPr>
+          <a:xfrm>
+            <a:off x="2804007" y="1595119"/>
+            <a:ext cx="1920240" cy="4161536"/>
+          </a:xfrm>
+          <a:prstGeom prst="rect">
+            <a:avLst/>
+          </a:prstGeom>
+        </p:spPr>
+      </p:pic>
+      <p:sp>
+        <p:nvSpPr>
+          <p:cNvPr id="9" name="TextBox 8"/>
+          <p:cNvSpPr txBox="1"/>
+          <p:nvPr/>
+        </p:nvSpPr>
+        <p:spPr>
+          <a:xfrm>
+            <a:off x="2804007" y="5870448"/>
+            <a:ext cx="1920240" cy="320040"/>
+          </a:xfrm>
+          <a:prstGeom prst="rect">
+            <a:avLst/>
+          </a:prstGeom>
+          <a:noFill/>
+        </p:spPr>
+        <p:txBody>
+          <a:bodyPr wrap="square" anchor="t" lIns="0" rIns="0" tIns="0" bIns="0">
+            <a:spAutoFit/>
+          </a:bodyPr>
+          <a:lstStyle/>
+          <a:p>
+            <a:pPr algn="ctr"/>
+            <a:r>
+              <a:rPr sz="1200" b="1" i="0">
+                <a:solidFill>
+                  <a:srgbClr val="444E57"/>
+                </a:solidFill>
+                <a:latin typeface="Segoe UI"/>
+              </a:rPr>
+              <a:t>Sign-up</a:t>
+            </a:r>
+          </a:p>
+        </p:txBody>
+      </p:sp>
+      <p:pic>
+        <p:nvPicPr>
+          <p:cNvPr id="10" name="Picture 9" descr="app-create-1.png"/>
+          <p:cNvPicPr>
+            <a:picLocks noChangeAspect="1"/>
+          </p:cNvPicPr>
+          <p:nvPr/>
+        </p:nvPicPr>
+        <p:blipFill>
+          <a:blip r:embed="rId4"/>
+          <a:stretch>
+            <a:fillRect/>
+          </a:stretch>
+        </p:blipFill>
+        <p:spPr>
+          <a:xfrm>
+            <a:off x="5135727" y="1595119"/>
+            <a:ext cx="1920240" cy="4161536"/>
+          </a:xfrm>
+          <a:prstGeom prst="rect">
+            <a:avLst/>
+          </a:prstGeom>
+        </p:spPr>
+      </p:pic>
+      <p:sp>
+        <p:nvSpPr>
+          <p:cNvPr id="11" name="TextBox 10"/>
+          <p:cNvSpPr txBox="1"/>
+          <p:nvPr/>
+        </p:nvSpPr>
+        <p:spPr>
+          <a:xfrm>
+            <a:off x="5135727" y="5870448"/>
+            <a:ext cx="1920240" cy="320040"/>
+          </a:xfrm>
+          <a:prstGeom prst="rect">
+            <a:avLst/>
+          </a:prstGeom>
+          <a:noFill/>
+        </p:spPr>
+        <p:txBody>
+          <a:bodyPr wrap="square" anchor="t" lIns="0" rIns="0" tIns="0" bIns="0">
+            <a:spAutoFit/>
+          </a:bodyPr>
+          <a:lstStyle/>
+          <a:p>
+            <a:pPr algn="ctr"/>
+            <a:r>
+              <a:rPr sz="1200" b="1" i="0">
+                <a:solidFill>
+                  <a:srgbClr val="444E57"/>
+                </a:solidFill>
+                <a:latin typeface="Segoe UI"/>
+              </a:rPr>
+              <a:t>Create persona</a:t>
+            </a:r>
+          </a:p>
+        </p:txBody>
+      </p:sp>
+      <p:pic>
+        <p:nvPicPr>
+          <p:cNvPr id="12" name="Picture 11" descr="app-create-3.png"/>
+          <p:cNvPicPr>
+            <a:picLocks noChangeAspect="1"/>
+          </p:cNvPicPr>
+          <p:nvPr/>
+        </p:nvPicPr>
+        <p:blipFill>
+          <a:blip r:embed="rId5"/>
+          <a:stretch>
+            <a:fillRect/>
+          </a:stretch>
+        </p:blipFill>
+        <p:spPr>
+          <a:xfrm>
+            <a:off x="7467447" y="1595119"/>
+            <a:ext cx="1920240" cy="4161536"/>
+          </a:xfrm>
+          <a:prstGeom prst="rect">
+            <a:avLst/>
+          </a:prstGeom>
+        </p:spPr>
+      </p:pic>
+      <p:sp>
+        <p:nvSpPr>
+          <p:cNvPr id="13" name="TextBox 12"/>
+          <p:cNvSpPr txBox="1"/>
+          <p:nvPr/>
+        </p:nvSpPr>
+        <p:spPr>
+          <a:xfrm>
+            <a:off x="7467447" y="5870448"/>
+            <a:ext cx="1920240" cy="320040"/>
+          </a:xfrm>
+          <a:prstGeom prst="rect">
+            <a:avLst/>
+          </a:prstGeom>
+          <a:noFill/>
+        </p:spPr>
+        <p:txBody>
+          <a:bodyPr wrap="square" anchor="t" lIns="0" rIns="0" tIns="0" bIns="0">
+            <a:spAutoFit/>
+          </a:bodyPr>
+          <a:lstStyle/>
+          <a:p>
+            <a:pPr algn="ctr"/>
+            <a:r>
+              <a:rPr sz="1200" b="1" i="0">
+                <a:solidFill>
+                  <a:srgbClr val="444E57"/>
+                </a:solidFill>
+                <a:latin typeface="Segoe UI"/>
+              </a:rPr>
+              <a:t>Add a voice</a:t>
+            </a:r>
+          </a:p>
+        </p:txBody>
+      </p:sp>
+      <p:pic>
+        <p:nvPicPr>
+          <p:cNvPr id="14" name="Picture 13" descr="app-voice.png"/>
+          <p:cNvPicPr>
+            <a:picLocks noChangeAspect="1"/>
+          </p:cNvPicPr>
+          <p:nvPr/>
+        </p:nvPicPr>
+        <p:blipFill>
+          <a:blip r:embed="rId6"/>
+          <a:stretch>
+            <a:fillRect/>
+          </a:stretch>
+        </p:blipFill>
+        <p:spPr>
+          <a:xfrm>
+            <a:off x="9799167" y="1595119"/>
+            <a:ext cx="1920240" cy="4161536"/>
+          </a:xfrm>
+          <a:prstGeom prst="rect">
+            <a:avLst/>
+          </a:prstGeom>
+        </p:spPr>
+      </p:pic>
+      <p:sp>
+        <p:nvSpPr>
+          <p:cNvPr id="15" name="TextBox 14"/>
+          <p:cNvSpPr txBox="1"/>
+          <p:nvPr/>
+        </p:nvSpPr>
+        <p:spPr>
+          <a:xfrm>
+            <a:off x="9799167" y="5870448"/>
+            <a:ext cx="1920240" cy="320040"/>
+          </a:xfrm>
+          <a:prstGeom prst="rect">
+            <a:avLst/>
+          </a:prstGeom>
+          <a:noFill/>
+        </p:spPr>
+        <p:txBody>
+          <a:bodyPr wrap="square" anchor="t" lIns="0" rIns="0" tIns="0" bIns="0">
+            <a:spAutoFit/>
+          </a:bodyPr>
+          <a:lstStyle/>
+          <a:p>
+            <a:pPr algn="ctr"/>
+            <a:r>
+              <a:rPr sz="1200" b="1" i="0">
+                <a:solidFill>
+                  <a:srgbClr val="444E57"/>
+                </a:solidFill>
+                <a:latin typeface="Segoe UI"/>
+              </a:rPr>
+              <a:t>Voice call</a:t>
+            </a:r>
+          </a:p>
+        </p:txBody>
+      </p:sp>
+      <p:sp>
+        <p:nvSpPr>
+          <p:cNvPr id="16" name="TextBox 15"/>
+          <p:cNvSpPr txBox="1"/>
+          <p:nvPr/>
+        </p:nvSpPr>
+        <p:spPr>
+          <a:xfrm>
+            <a:off x="548640" y="6419088"/>
+            <a:ext cx="8229600" cy="320040"/>
+          </a:xfrm>
+          <a:prstGeom prst="rect">
+            <a:avLst/>
+          </a:prstGeom>
+          <a:noFill/>
+        </p:spPr>
+        <p:txBody>
+          <a:bodyPr wrap="square" anchor="t" lIns="0" rIns="0" tIns="0" bIns="0">
+            <a:spAutoFit/>
+          </a:bodyPr>
+          <a:lstStyle/>
+          <a:p>
             <a:pPr algn="l"/>
             <a:r>
               <a:rPr sz="900" b="0" i="0">
@@ -9162,7 +9140,7 @@
       </p:sp>
       <p:sp>
         <p:nvSpPr>
-          <p:cNvPr id="15" name="TextBox 14"/>
+          <p:cNvPr id="17" name="TextBox 16"/>
           <p:cNvSpPr txBox="1"/>
           <p:nvPr/>
         </p:nvSpPr>

</xml_diff>

<commit_message>
Align presentation future work with the report
Add real-time full-duplex (streaming) voice and a persona avatar to the
future-work slide (and its notes), and group the slide into Limitations /
Future work, matching the report's future-work section.

Co-Authored-By: Claude Opus 4.8 <noreply@anthropic.com>
</commit_message>
<xml_diff>
--- a/backend/docs/report/NinaivX-Presentation.pptx
+++ b/backend/docs/report/NinaivX-Presentation.pptx
@@ -725,7 +725,7 @@
           <a:lstStyle/>
           <a:p>
             <a:r>
-              <a:t>Being honest about limits: the sample is small and self-selected, it measures perceptions rather than long-term wellbeing, and — by ethical necessity — I didn't test with actually bereaved people. The future work follows directly: better voice, retrieval-based grounding to fix the personal-fact gap, and a larger longitudinal study.</a:t>
+              <a:t>Being honest about limits: the sample is small and self-selected, it measures perceptions rather than long-term wellbeing, and — by ethical necessity — I didn't test with actually bereaved people. The future work follows directly: better voice naturalness, retrieval-based grounding to fix the personal-fact gap, real-time full-duplex streaming voice for lower latency, a persona avatar that users asked for, and a larger longitudinal study.</a:t>
             </a:r>
           </a:p>
         </p:txBody>
@@ -5623,11 +5623,11 @@
                 <a:spcPts val="0"/>
               </a:spcBef>
               <a:spcAft>
-                <a:spcPts val="1100"/>
+                <a:spcPts val="800"/>
               </a:spcAft>
             </a:pPr>
             <a:r>
-              <a:rPr sz="1900" b="1" i="0">
+              <a:rPr sz="1800" b="1" i="0">
                 <a:solidFill>
                   <a:srgbClr val="2A6F6B"/>
                 </a:solidFill>
@@ -5636,13 +5636,69 @@
               <a:t>▪  </a:t>
             </a:r>
             <a:r>
-              <a:rPr sz="1900" b="0" i="0">
+              <a:rPr sz="1800" b="0" i="0">
                 <a:solidFill>
                   <a:srgbClr val="444E57"/>
                 </a:solidFill>
                 <a:latin typeface="Segoe UI"/>
               </a:rPr>
-              <a:t>Small (n = 21), self-selected sample; measures perceptions, not long-term wellbeing.</a:t>
+              <a:t>Limitations</a:t>
+            </a:r>
+          </a:p>
+          <a:p>
+            <a:pPr lvl="1">
+              <a:spcBef>
+                <a:spcPts val="0"/>
+              </a:spcBef>
+              <a:spcAft>
+                <a:spcPts val="800"/>
+              </a:spcAft>
+            </a:pPr>
+            <a:r>
+              <a:rPr sz="1600" b="0" i="0">
+                <a:solidFill>
+                  <a:srgbClr val="C97A1A"/>
+                </a:solidFill>
+                <a:latin typeface="Segoe UI"/>
+              </a:rPr>
+              <a:t>      –  </a:t>
+            </a:r>
+            <a:r>
+              <a:rPr sz="1600" b="0" i="0">
+                <a:solidFill>
+                  <a:srgbClr val="444E57"/>
+                </a:solidFill>
+                <a:latin typeface="Segoe UI"/>
+              </a:rPr>
+              <a:t>small, self-selected sample (n = 21); measures perceptions, not long-term wellbeing</a:t>
+            </a:r>
+          </a:p>
+          <a:p>
+            <a:pPr lvl="1">
+              <a:spcBef>
+                <a:spcPts val="0"/>
+              </a:spcBef>
+              <a:spcAft>
+                <a:spcPts val="800"/>
+              </a:spcAft>
+            </a:pPr>
+            <a:r>
+              <a:rPr sz="1600" b="0" i="0">
+                <a:solidFill>
+                  <a:srgbClr val="C97A1A"/>
+                </a:solidFill>
+                <a:latin typeface="Segoe UI"/>
+              </a:rPr>
+              <a:t>      –  </a:t>
+            </a:r>
+            <a:r>
+              <a:rPr sz="1600" b="0" i="0">
+                <a:solidFill>
+                  <a:srgbClr val="444E57"/>
+                </a:solidFill>
+                <a:latin typeface="Segoe UI"/>
+              </a:rPr>
+              <a:t>by ethical design, no genuinely bereaved users took part</a:t>
             </a:r>
           </a:p>
           <a:p>
@@ -5651,11 +5707,11 @@
                 <a:spcPts val="0"/>
               </a:spcBef>
               <a:spcAft>
-                <a:spcPts val="1100"/>
+                <a:spcPts val="800"/>
               </a:spcAft>
             </a:pPr>
             <a:r>
-              <a:rPr sz="1900" b="1" i="0">
+              <a:rPr sz="1800" b="1" i="0">
                 <a:solidFill>
                   <a:srgbClr val="2A6F6B"/>
                 </a:solidFill>
@@ -5664,13 +5720,13 @@
               <a:t>▪  </a:t>
             </a:r>
             <a:r>
-              <a:rPr sz="1900" b="0" i="0">
+              <a:rPr sz="1800" b="0" i="0">
                 <a:solidFill>
                   <a:srgbClr val="444E57"/>
                 </a:solidFill>
                 <a:latin typeface="Segoe UI"/>
               </a:rPr>
-              <a:t>By ethical design, no genuinely bereaved users took part.</a:t>
+              <a:t>Future work</a:t>
             </a:r>
           </a:p>
           <a:p>
@@ -5679,11 +5735,11 @@
                 <a:spcPts val="0"/>
               </a:spcBef>
               <a:spcAft>
-                <a:spcPts val="1100"/>
+                <a:spcPts val="800"/>
               </a:spcAft>
             </a:pPr>
             <a:r>
-              <a:rPr sz="1700" b="0" i="0">
+              <a:rPr sz="1600" b="0" i="0">
                 <a:solidFill>
                   <a:srgbClr val="C97A1A"/>
                 </a:solidFill>
@@ -5692,97 +5748,125 @@
               <a:t>      –  </a:t>
             </a:r>
             <a:r>
-              <a:rPr sz="1700" b="0" i="0">
+              <a:rPr sz="1600" b="0" i="0">
                 <a:solidFill>
                   <a:srgbClr val="444E57"/>
                 </a:solidFill>
                 <a:latin typeface="Segoe UI"/>
               </a:rPr>
-              <a:t/>
-            </a:r>
-          </a:p>
-          <a:p>
-            <a:pPr>
+              <a:t>improve voice naturalness — users’ top request</a:t>
+            </a:r>
+          </a:p>
+          <a:p>
+            <a:pPr lvl="1">
               <a:spcBef>
                 <a:spcPts val="0"/>
               </a:spcBef>
               <a:spcAft>
-                <a:spcPts val="1100"/>
+                <a:spcPts val="800"/>
               </a:spcAft>
             </a:pPr>
             <a:r>
-              <a:rPr sz="1900" b="1" i="0">
-                <a:solidFill>
-                  <a:srgbClr val="2A6F6B"/>
-                </a:solidFill>
-                <a:latin typeface="Segoe UI"/>
-              </a:rPr>
-              <a:t>▪  </a:t>
-            </a:r>
-            <a:r>
-              <a:rPr sz="1900" b="0" i="0">
+              <a:rPr sz="1600" b="0" i="0">
+                <a:solidFill>
+                  <a:srgbClr val="C97A1A"/>
+                </a:solidFill>
+                <a:latin typeface="Segoe UI"/>
+              </a:rPr>
+              <a:t>      –  </a:t>
+            </a:r>
+            <a:r>
+              <a:rPr sz="1600" b="0" i="0">
                 <a:solidFill>
                   <a:srgbClr val="444E57"/>
                 </a:solidFill>
                 <a:latin typeface="Segoe UI"/>
               </a:rPr>
-              <a:t>Future: improve voice naturalness (users’ top request).</a:t>
-            </a:r>
-          </a:p>
-          <a:p>
-            <a:pPr>
+              <a:t>document-grounded retrieval (RAG) to fix personal-fact confabulation</a:t>
+            </a:r>
+          </a:p>
+          <a:p>
+            <a:pPr lvl="1">
               <a:spcBef>
                 <a:spcPts val="0"/>
               </a:spcBef>
               <a:spcAft>
-                <a:spcPts val="1100"/>
+                <a:spcPts val="800"/>
               </a:spcAft>
             </a:pPr>
             <a:r>
-              <a:rPr sz="1900" b="1" i="0">
-                <a:solidFill>
-                  <a:srgbClr val="2A6F6B"/>
-                </a:solidFill>
-                <a:latin typeface="Segoe UI"/>
-              </a:rPr>
-              <a:t>▪  </a:t>
-            </a:r>
-            <a:r>
-              <a:rPr sz="1900" b="0" i="0">
+              <a:rPr sz="1600" b="0" i="0">
+                <a:solidFill>
+                  <a:srgbClr val="C97A1A"/>
+                </a:solidFill>
+                <a:latin typeface="Segoe UI"/>
+              </a:rPr>
+              <a:t>      –  </a:t>
+            </a:r>
+            <a:r>
+              <a:rPr sz="1600" b="0" i="0">
                 <a:solidFill>
                   <a:srgbClr val="444E57"/>
                 </a:solidFill>
                 <a:latin typeface="Segoe UI"/>
               </a:rPr>
-              <a:t>Future: document-grounded retrieval (RAG) to fix personal-fact confabulation.</a:t>
-            </a:r>
-          </a:p>
-          <a:p>
-            <a:pPr>
+              <a:t>real-time, full-duplex (streaming) voice for lower latency</a:t>
+            </a:r>
+          </a:p>
+          <a:p>
+            <a:pPr lvl="1">
               <a:spcBef>
                 <a:spcPts val="0"/>
               </a:spcBef>
               <a:spcAft>
-                <a:spcPts val="1100"/>
+                <a:spcPts val="800"/>
               </a:spcAft>
             </a:pPr>
             <a:r>
-              <a:rPr sz="1900" b="1" i="0">
-                <a:solidFill>
-                  <a:srgbClr val="2A6F6B"/>
-                </a:solidFill>
-                <a:latin typeface="Segoe UI"/>
-              </a:rPr>
-              <a:t>▪  </a:t>
-            </a:r>
-            <a:r>
-              <a:rPr sz="1900" b="0" i="0">
+              <a:rPr sz="1600" b="0" i="0">
+                <a:solidFill>
+                  <a:srgbClr val="C97A1A"/>
+                </a:solidFill>
+                <a:latin typeface="Segoe UI"/>
+              </a:rPr>
+              <a:t>      –  </a:t>
+            </a:r>
+            <a:r>
+              <a:rPr sz="1600" b="0" i="0">
                 <a:solidFill>
                   <a:srgbClr val="444E57"/>
                 </a:solidFill>
                 <a:latin typeface="Segoe UI"/>
               </a:rPr>
-              <a:t>Future: a larger, longitudinal study.</a:t>
+              <a:t>a persona avatar / photo — a common user request</a:t>
+            </a:r>
+          </a:p>
+          <a:p>
+            <a:pPr lvl="1">
+              <a:spcBef>
+                <a:spcPts val="0"/>
+              </a:spcBef>
+              <a:spcAft>
+                <a:spcPts val="800"/>
+              </a:spcAft>
+            </a:pPr>
+            <a:r>
+              <a:rPr sz="1600" b="0" i="0">
+                <a:solidFill>
+                  <a:srgbClr val="C97A1A"/>
+                </a:solidFill>
+                <a:latin typeface="Segoe UI"/>
+              </a:rPr>
+              <a:t>      –  </a:t>
+            </a:r>
+            <a:r>
+              <a:rPr sz="1600" b="0" i="0">
+                <a:solidFill>
+                  <a:srgbClr val="444E57"/>
+                </a:solidFill>
+                <a:latin typeface="Segoe UI"/>
+              </a:rPr>
+              <a:t>a larger, longitudinal study</a:t>
             </a:r>
           </a:p>
         </p:txBody>

</xml_diff>

<commit_message>
Give the user study its own visual on the evaluation slide
Rework slide 4 into two side-by-side studies with real data: the user-study
Likert chart (21 participants) on the left with its headline stats, and the
controlled fabrication chart on the right with 83%->28% / 100%->~0% callouts.
Previously the user study appeared only as a single stat box.

Co-Authored-By: Claude Opus 4.8 <noreply@anthropic.com>
</commit_message>
<xml_diff>
--- a/backend/docs/report/NinaivX-Presentation.pptx
+++ b/backend/docs/report/NinaivX-Presentation.pptx
@@ -722,7 +722,7 @@
           <a:lstStyle/>
           <a:p>
             <a:r>
-              <a:t>I evaluated it two ways. First, a controlled experiment: same AI model on both sides, changing only my grounding versus an unconstrained baseline. Fabrication dropped from 83% to 28% overall, and fabrication about events after death fell from 100% to essentially zero. That directly answers RQ1. Second, a user study — 21 adults, ethics-approved and anonymous — rated it 4.6 out of 5, with 90% trusting it not to make things up. The honest weak spot users flagged was voice naturalness.</a:t>
+              <a:t>I evaluated it two ways. On the left is my user study — 21 real participants, ethics-approved, remote and anonymous. The chart shows their ratings: an overall 4.6 out of 5, everyone found it easy to use and comfortable, and 90% trusted it not to make things up. The honest weak spot they flagged was voice naturalness. On the right is the controlled fabrication test: same AI model, changing only my grounding versus an unconstrained baseline — fabrication dropped from 83% to 28% overall, and fabrication about events after death fell from 100% to essentially zero. Together these answer both research questions: real users rate it highly, and I measured that it genuinely reduces fabrication.</a:t>
             </a:r>
           </a:p>
         </p:txBody>
@@ -5176,7 +5176,7 @@
                 </a:solidFill>
                 <a:latin typeface="Segoe UI"/>
               </a:rPr>
-              <a:t>Evaluation — it works, and I measured it</a:t>
+              <a:t>Evaluation — two studies with real evidence</a:t>
             </a:r>
           </a:p>
         </p:txBody>
@@ -5225,9 +5225,44 @@
           </a:p>
         </p:txBody>
       </p:sp>
+      <p:sp>
+        <p:nvSpPr>
+          <p:cNvPr id="5" name="TextBox 4"/>
+          <p:cNvSpPr txBox="1"/>
+          <p:nvPr/>
+        </p:nvSpPr>
+        <p:spPr>
+          <a:xfrm>
+            <a:off x="457200" y="1417320"/>
+            <a:ext cx="5760720" cy="365760"/>
+          </a:xfrm>
+          <a:prstGeom prst="rect">
+            <a:avLst/>
+          </a:prstGeom>
+          <a:noFill/>
+        </p:spPr>
+        <p:txBody>
+          <a:bodyPr wrap="square" anchor="t" lIns="0" rIns="0" tIns="0" bIns="0">
+            <a:spAutoFit/>
+          </a:bodyPr>
+          <a:lstStyle/>
+          <a:p>
+            <a:pPr algn="l"/>
+            <a:r>
+              <a:rPr sz="1500" b="1" i="0">
+                <a:solidFill>
+                  <a:srgbClr val="2A6F6B"/>
+                </a:solidFill>
+                <a:latin typeface="Segoe UI"/>
+              </a:rPr>
+              <a:t>1.  User study — 21 participants (ethics-approved)</a:t>
+            </a:r>
+          </a:p>
+        </p:txBody>
+      </p:sp>
       <p:pic>
         <p:nvPicPr>
-          <p:cNvPr id="5" name="Picture 4" descr="NinaivX-Fabrication.png"/>
+          <p:cNvPr id="6" name="Picture 5" descr="NinaivX-Results-Likert.png"/>
           <p:cNvPicPr>
             <a:picLocks noChangeAspect="1"/>
           </p:cNvPicPr>
@@ -5241,8 +5276,8 @@
         </p:blipFill>
         <p:spPr>
           <a:xfrm>
-            <a:off x="457200" y="1790522"/>
-            <a:ext cx="6035040" cy="3368394"/>
+            <a:off x="589298" y="1783080"/>
+            <a:ext cx="5405083" cy="3291840"/>
           </a:xfrm>
           <a:prstGeom prst="rect">
             <a:avLst/>
@@ -5251,14 +5286,14 @@
       </p:pic>
       <p:sp>
         <p:nvSpPr>
-          <p:cNvPr id="6" name="TextBox 5"/>
+          <p:cNvPr id="7" name="TextBox 6"/>
           <p:cNvSpPr txBox="1"/>
           <p:nvPr/>
         </p:nvSpPr>
         <p:spPr>
           <a:xfrm>
-            <a:off x="457200" y="5532120"/>
-            <a:ext cx="6035040" cy="365760"/>
+            <a:off x="457200" y="5166360"/>
+            <a:ext cx="5760720" cy="914400"/>
           </a:xfrm>
           <a:prstGeom prst="rect">
             <a:avLst/>
@@ -5271,29 +5306,88 @@
           </a:bodyPr>
           <a:lstStyle/>
           <a:p>
-            <a:pPr algn="ctr"/>
-            <a:r>
-              <a:rPr sz="1200" b="0" i="1">
+            <a:pPr algn="l"/>
+            <a:r>
+              <a:rPr sz="1300" b="0" i="0">
                 <a:solidFill>
                   <a:srgbClr val="444E57"/>
                 </a:solidFill>
                 <a:latin typeface="Segoe UI"/>
               </a:rPr>
-              <a:t>Controlled test: same model, only the grounding changed</a:t>
-            </a:r>
-          </a:p>
-        </p:txBody>
-      </p:sp>
-      <p:sp>
-        <p:nvSpPr>
-          <p:cNvPr id="7" name="Rounded Rectangle 6"/>
+              <a:t>Overall 4.6 / 5.  Everyone found it easy and comfortable; 90% trusted it not to “make things up.”</a:t>
+            </a:r>
+          </a:p>
+        </p:txBody>
+      </p:sp>
+      <p:sp>
+        <p:nvSpPr>
+          <p:cNvPr id="8" name="TextBox 7"/>
+          <p:cNvSpPr txBox="1"/>
+          <p:nvPr/>
+        </p:nvSpPr>
+        <p:spPr>
+          <a:xfrm>
+            <a:off x="6400800" y="1417320"/>
+            <a:ext cx="5486400" cy="365760"/>
+          </a:xfrm>
+          <a:prstGeom prst="rect">
+            <a:avLst/>
+          </a:prstGeom>
+          <a:noFill/>
+        </p:spPr>
+        <p:txBody>
+          <a:bodyPr wrap="square" anchor="t" lIns="0" rIns="0" tIns="0" bIns="0">
+            <a:spAutoFit/>
+          </a:bodyPr>
+          <a:lstStyle/>
+          <a:p>
+            <a:pPr algn="l"/>
+            <a:r>
+              <a:rPr sz="1500" b="1" i="0">
+                <a:solidFill>
+                  <a:srgbClr val="2A6F6B"/>
+                </a:solidFill>
+                <a:latin typeface="Segoe UI"/>
+              </a:rPr>
+              <a:t>2.  Controlled fabrication test</a:t>
+            </a:r>
+          </a:p>
+        </p:txBody>
+      </p:sp>
+      <p:pic>
+        <p:nvPicPr>
+          <p:cNvPr id="9" name="Picture 8" descr="NinaivX-Fabrication.png"/>
+          <p:cNvPicPr>
+            <a:picLocks noChangeAspect="1"/>
+          </p:cNvPicPr>
+          <p:nvPr/>
+        </p:nvPicPr>
+        <p:blipFill>
+          <a:blip r:embed="rId3"/>
+          <a:stretch>
+            <a:fillRect/>
+          </a:stretch>
+        </p:blipFill>
+        <p:spPr>
+          <a:xfrm>
+            <a:off x="6558915" y="1783080"/>
+            <a:ext cx="5078730" cy="2834640"/>
+          </a:xfrm>
+          <a:prstGeom prst="rect">
+            <a:avLst/>
+          </a:prstGeom>
+        </p:spPr>
+      </p:pic>
+      <p:sp>
+        <p:nvSpPr>
+          <p:cNvPr id="10" name="Rounded Rectangle 9"/>
           <p:cNvSpPr/>
           <p:nvPr/>
         </p:nvSpPr>
         <p:spPr>
           <a:xfrm>
-            <a:off x="6766560" y="1554480"/>
-            <a:ext cx="4937760" cy="1143000"/>
+            <a:off x="6400800" y="4754880"/>
+            <a:ext cx="2606040" cy="1234440"/>
           </a:xfrm>
           <a:prstGeom prst="roundRect">
             <a:avLst/>
@@ -5332,14 +5426,14 @@
       </p:sp>
       <p:sp>
         <p:nvSpPr>
-          <p:cNvPr id="8" name="TextBox 7"/>
+          <p:cNvPr id="11" name="TextBox 10"/>
           <p:cNvSpPr txBox="1"/>
           <p:nvPr/>
         </p:nvSpPr>
         <p:spPr>
           <a:xfrm>
-            <a:off x="6858000" y="1691639"/>
-            <a:ext cx="4754880" cy="914400"/>
+            <a:off x="6492240" y="4892040"/>
+            <a:ext cx="2423160" cy="1005840"/>
           </a:xfrm>
           <a:prstGeom prst="rect">
             <a:avLst/>
@@ -5360,7 +5454,7 @@
                 </a:solidFill>
                 <a:latin typeface="Segoe UI"/>
               </a:rPr>
-              <a:t>83%  →  28%</a:t>
+              <a:t>83% → 28%</a:t>
             </a:r>
           </a:p>
           <a:p>
@@ -5372,21 +5466,21 @@
                 </a:solidFill>
                 <a:latin typeface="Segoe UI"/>
               </a:rPr>
-              <a:t>overall fabrication rate</a:t>
-            </a:r>
-          </a:p>
-        </p:txBody>
-      </p:sp>
-      <p:sp>
-        <p:nvSpPr>
-          <p:cNvPr id="9" name="Rounded Rectangle 8"/>
+              <a:t>overall fabrication</a:t>
+            </a:r>
+          </a:p>
+        </p:txBody>
+      </p:sp>
+      <p:sp>
+        <p:nvSpPr>
+          <p:cNvPr id="12" name="Rounded Rectangle 11"/>
           <p:cNvSpPr/>
           <p:nvPr/>
         </p:nvSpPr>
         <p:spPr>
           <a:xfrm>
-            <a:off x="6766560" y="2788920"/>
-            <a:ext cx="4937760" cy="1143000"/>
+            <a:off x="9144000" y="4754880"/>
+            <a:ext cx="2606040" cy="1234440"/>
           </a:xfrm>
           <a:prstGeom prst="roundRect">
             <a:avLst/>
@@ -5425,14 +5519,14 @@
       </p:sp>
       <p:sp>
         <p:nvSpPr>
-          <p:cNvPr id="10" name="TextBox 9"/>
+          <p:cNvPr id="13" name="TextBox 12"/>
           <p:cNvSpPr txBox="1"/>
           <p:nvPr/>
         </p:nvSpPr>
         <p:spPr>
           <a:xfrm>
-            <a:off x="6858000" y="2926079"/>
-            <a:ext cx="4754880" cy="914400"/>
+            <a:off x="9235440" y="4892040"/>
+            <a:ext cx="2423160" cy="1005840"/>
           </a:xfrm>
           <a:prstGeom prst="rect">
             <a:avLst/>
@@ -5453,7 +5547,7 @@
                 </a:solidFill>
                 <a:latin typeface="Segoe UI"/>
               </a:rPr>
-              <a:t>100%  →  ~0%</a:t>
+              <a:t>100% → ~0%</a:t>
             </a:r>
           </a:p>
           <a:p>
@@ -5465,135 +5559,7 @@
                 </a:solidFill>
                 <a:latin typeface="Segoe UI"/>
               </a:rPr>
-              <a:t>fabrication about post-death events</a:t>
-            </a:r>
-          </a:p>
-        </p:txBody>
-      </p:sp>
-      <p:sp>
-        <p:nvSpPr>
-          <p:cNvPr id="11" name="Rounded Rectangle 10"/>
-          <p:cNvSpPr/>
-          <p:nvPr/>
-        </p:nvSpPr>
-        <p:spPr>
-          <a:xfrm>
-            <a:off x="6766560" y="4023360"/>
-            <a:ext cx="4937760" cy="1143000"/>
-          </a:xfrm>
-          <a:prstGeom prst="roundRect">
-            <a:avLst/>
-          </a:prstGeom>
-          <a:solidFill>
-            <a:srgbClr val="EEF4F3"/>
-          </a:solidFill>
-          <a:ln w="19050">
-            <a:solidFill>
-              <a:srgbClr val="2A6F6B"/>
-            </a:solidFill>
-          </a:ln>
-          <a:effectLst/>
-        </p:spPr>
-        <p:style>
-          <a:lnRef idx="1">
-            <a:schemeClr val="accent1"/>
-          </a:lnRef>
-          <a:fillRef idx="3">
-            <a:schemeClr val="accent1"/>
-          </a:fillRef>
-          <a:effectRef idx="2">
-            <a:schemeClr val="accent1"/>
-          </a:effectRef>
-          <a:fontRef idx="minor">
-            <a:schemeClr val="lt1"/>
-          </a:fontRef>
-        </p:style>
-        <p:txBody>
-          <a:bodyPr rtlCol="0" anchor="ctr"/>
-          <a:lstStyle/>
-          <a:p>
-            <a:pPr algn="ctr"/>
-          </a:p>
-        </p:txBody>
-      </p:sp>
-      <p:sp>
-        <p:nvSpPr>
-          <p:cNvPr id="12" name="TextBox 11"/>
-          <p:cNvSpPr txBox="1"/>
-          <p:nvPr/>
-        </p:nvSpPr>
-        <p:spPr>
-          <a:xfrm>
-            <a:off x="6858000" y="4160520"/>
-            <a:ext cx="4754880" cy="914400"/>
-          </a:xfrm>
-          <a:prstGeom prst="rect">
-            <a:avLst/>
-          </a:prstGeom>
-          <a:noFill/>
-        </p:spPr>
-        <p:txBody>
-          <a:bodyPr wrap="square" anchor="ctr" lIns="0" rIns="0" tIns="0" bIns="0">
-            <a:spAutoFit/>
-          </a:bodyPr>
-          <a:lstStyle/>
-          <a:p>
-            <a:pPr algn="ctr"/>
-            <a:r>
-              <a:rPr sz="2400" b="1" i="0">
-                <a:solidFill>
-                  <a:srgbClr val="2A6F6B"/>
-                </a:solidFill>
-                <a:latin typeface="Segoe UI"/>
-              </a:rPr>
-              <a:t>4.6 / 5</a:t>
-            </a:r>
-          </a:p>
-          <a:p>
-            <a:pPr algn="ctr"/>
-            <a:r>
-              <a:rPr sz="1200" b="0" i="0">
-                <a:solidFill>
-                  <a:srgbClr val="444E57"/>
-                </a:solidFill>
-                <a:latin typeface="Segoe UI"/>
-              </a:rPr>
-              <a:t>user study rating (n = 21, ethics-approved)</a:t>
-            </a:r>
-          </a:p>
-        </p:txBody>
-      </p:sp>
-      <p:sp>
-        <p:nvSpPr>
-          <p:cNvPr id="13" name="TextBox 12"/>
-          <p:cNvSpPr txBox="1"/>
-          <p:nvPr/>
-        </p:nvSpPr>
-        <p:spPr>
-          <a:xfrm>
-            <a:off x="6766560" y="5303520"/>
-            <a:ext cx="4937760" cy="914400"/>
-          </a:xfrm>
-          <a:prstGeom prst="rect">
-            <a:avLst/>
-          </a:prstGeom>
-          <a:noFill/>
-        </p:spPr>
-        <p:txBody>
-          <a:bodyPr wrap="square" anchor="t" lIns="0" rIns="0" tIns="0" bIns="0">
-            <a:spAutoFit/>
-          </a:bodyPr>
-          <a:lstStyle/>
-          <a:p>
-            <a:pPr algn="l"/>
-            <a:r>
-              <a:rPr sz="1400" b="0" i="0">
-                <a:solidFill>
-                  <a:srgbClr val="444E57"/>
-                </a:solidFill>
-                <a:latin typeface="Segoe UI"/>
-              </a:rPr>
-              <a:t>90% trusted it not to “make things up” and knew it was an AI. Weakest point: voice naturalness.</a:t>
+              <a:t>post-death events</a:t>
             </a:r>
           </a:p>
         </p:txBody>

</xml_diff>

<commit_message>
Add a 'Scan to try it' QR to the closing slide
Add the stable /app QR (https://ninaivx.onrender.com/app) to slide 5 so markers
can try NinaivX on their own phone via Expo Go. The QR encodes the fixed redirect
link, so it stays valid even if the Expo tunnel URL/port changes.

Co-Authored-By: Claude Opus 4.8 <noreply@anthropic.com>
</commit_message>
<xml_diff>
--- a/backend/docs/report/NinaivX-Presentation.pptx
+++ b/backend/docs/report/NinaivX-Presentation.pptx
@@ -5784,7 +5784,7 @@
         <p:spPr>
           <a:xfrm>
             <a:off x="594360" y="1600200"/>
-            <a:ext cx="10972800" cy="4754880"/>
+            <a:ext cx="8138160" cy="4754880"/>
           </a:xfrm>
           <a:prstGeom prst="rect">
             <a:avLst/>
@@ -5918,14 +5918,14 @@
         </p:nvSpPr>
         <p:spPr>
           <a:xfrm>
-            <a:off x="594360" y="5257800"/>
-            <a:ext cx="10972800" cy="914400"/>
+            <a:off x="9189720" y="1554480"/>
+            <a:ext cx="2514600" cy="3108960"/>
           </a:xfrm>
           <a:prstGeom prst="roundRect">
             <a:avLst/>
           </a:prstGeom>
           <a:solidFill>
-            <a:srgbClr val="2A6F6B"/>
+            <a:srgbClr val="EEF4F3"/>
           </a:solidFill>
           <a:ln w="19050">
             <a:solidFill>
@@ -5956,16 +5956,40 @@
           </a:p>
         </p:txBody>
       </p:sp>
-      <p:sp>
-        <p:nvSpPr>
-          <p:cNvPr id="7" name="TextBox 6"/>
+      <p:pic>
+        <p:nvPicPr>
+          <p:cNvPr id="7" name="Picture 6" descr="qr-tryit.png"/>
+          <p:cNvPicPr>
+            <a:picLocks noChangeAspect="1"/>
+          </p:cNvPicPr>
+          <p:nvPr/>
+        </p:nvPicPr>
+        <p:blipFill>
+          <a:blip r:embed="rId2"/>
+          <a:stretch>
+            <a:fillRect/>
+          </a:stretch>
+        </p:blipFill>
+        <p:spPr>
+          <a:xfrm>
+            <a:off x="9326880" y="1737360"/>
+            <a:ext cx="2240280" cy="2240280"/>
+          </a:xfrm>
+          <a:prstGeom prst="rect">
+            <a:avLst/>
+          </a:prstGeom>
+        </p:spPr>
+      </p:pic>
+      <p:sp>
+        <p:nvSpPr>
+          <p:cNvPr id="8" name="TextBox 7"/>
           <p:cNvSpPr txBox="1"/>
           <p:nvPr/>
         </p:nvSpPr>
         <p:spPr>
           <a:xfrm>
-            <a:off x="594360" y="5257800"/>
-            <a:ext cx="10972800" cy="914400"/>
+            <a:off x="9235440" y="4023360"/>
+            <a:ext cx="2423160" cy="731520"/>
           </a:xfrm>
           <a:prstGeom prst="rect">
             <a:avLst/>
@@ -5973,34 +5997,92 @@
           <a:noFill/>
         </p:spPr>
         <p:txBody>
-          <a:bodyPr wrap="square" anchor="ctr" lIns="0" rIns="0" tIns="0" bIns="0">
+          <a:bodyPr wrap="square" anchor="t" lIns="0" rIns="0" tIns="0" bIns="0">
             <a:spAutoFit/>
           </a:bodyPr>
           <a:lstStyle/>
           <a:p>
             <a:pPr algn="ctr"/>
             <a:r>
-              <a:rPr sz="2600" b="1" i="0">
-                <a:solidFill>
-                  <a:srgbClr val="FFFFFF"/>
+              <a:rPr sz="1300" b="1" i="0">
+                <a:solidFill>
+                  <a:srgbClr val="2A6F6B"/>
                 </a:solidFill>
                 <a:latin typeface="Segoe UI"/>
               </a:rPr>
-              <a:t>Thank you  —  questions?</a:t>
-            </a:r>
-          </a:p>
-        </p:txBody>
-      </p:sp>
-      <p:sp>
-        <p:nvSpPr>
-          <p:cNvPr id="8" name="TextBox 7"/>
+              <a:t>Scan to try it</a:t>
+            </a:r>
+          </a:p>
+          <a:p>
+            <a:pPr algn="ctr"/>
+            <a:r>
+              <a:rPr sz="1050" b="0" i="0">
+                <a:solidFill>
+                  <a:srgbClr val="444E57"/>
+                </a:solidFill>
+                <a:latin typeface="Segoe UI"/>
+              </a:rPr>
+              <a:t>(free Expo Go app)</a:t>
+            </a:r>
+          </a:p>
+        </p:txBody>
+      </p:sp>
+      <p:sp>
+        <p:nvSpPr>
+          <p:cNvPr id="9" name="Rounded Rectangle 8"/>
+          <p:cNvSpPr/>
+          <p:nvPr/>
+        </p:nvSpPr>
+        <p:spPr>
+          <a:xfrm>
+            <a:off x="594360" y="5257800"/>
+            <a:ext cx="10972800" cy="914400"/>
+          </a:xfrm>
+          <a:prstGeom prst="roundRect">
+            <a:avLst/>
+          </a:prstGeom>
+          <a:solidFill>
+            <a:srgbClr val="2A6F6B"/>
+          </a:solidFill>
+          <a:ln w="19050">
+            <a:solidFill>
+              <a:srgbClr val="2A6F6B"/>
+            </a:solidFill>
+          </a:ln>
+          <a:effectLst/>
+        </p:spPr>
+        <p:style>
+          <a:lnRef idx="1">
+            <a:schemeClr val="accent1"/>
+          </a:lnRef>
+          <a:fillRef idx="3">
+            <a:schemeClr val="accent1"/>
+          </a:fillRef>
+          <a:effectRef idx="2">
+            <a:schemeClr val="accent1"/>
+          </a:effectRef>
+          <a:fontRef idx="minor">
+            <a:schemeClr val="lt1"/>
+          </a:fontRef>
+        </p:style>
+        <p:txBody>
+          <a:bodyPr rtlCol="0" anchor="ctr"/>
+          <a:lstStyle/>
+          <a:p>
+            <a:pPr algn="ctr"/>
+          </a:p>
+        </p:txBody>
+      </p:sp>
+      <p:sp>
+        <p:nvSpPr>
+          <p:cNvPr id="10" name="TextBox 9"/>
           <p:cNvSpPr txBox="1"/>
           <p:nvPr/>
         </p:nvSpPr>
         <p:spPr>
           <a:xfrm>
-            <a:off x="548640" y="6419088"/>
-            <a:ext cx="8229600" cy="320040"/>
+            <a:off x="594360" y="5257800"/>
+            <a:ext cx="10972800" cy="914400"/>
           </a:xfrm>
           <a:prstGeom prst="rect">
             <a:avLst/>
@@ -6008,6 +6090,41 @@
           <a:noFill/>
         </p:spPr>
         <p:txBody>
+          <a:bodyPr wrap="square" anchor="ctr" lIns="0" rIns="0" tIns="0" bIns="0">
+            <a:spAutoFit/>
+          </a:bodyPr>
+          <a:lstStyle/>
+          <a:p>
+            <a:pPr algn="ctr"/>
+            <a:r>
+              <a:rPr sz="2600" b="1" i="0">
+                <a:solidFill>
+                  <a:srgbClr val="FFFFFF"/>
+                </a:solidFill>
+                <a:latin typeface="Segoe UI"/>
+              </a:rPr>
+              <a:t>Thank you  —  questions?</a:t>
+            </a:r>
+          </a:p>
+        </p:txBody>
+      </p:sp>
+      <p:sp>
+        <p:nvSpPr>
+          <p:cNvPr id="11" name="TextBox 10"/>
+          <p:cNvSpPr txBox="1"/>
+          <p:nvPr/>
+        </p:nvSpPr>
+        <p:spPr>
+          <a:xfrm>
+            <a:off x="548640" y="6419088"/>
+            <a:ext cx="8229600" cy="320040"/>
+          </a:xfrm>
+          <a:prstGeom prst="rect">
+            <a:avLst/>
+          </a:prstGeom>
+          <a:noFill/>
+        </p:spPr>
+        <p:txBody>
           <a:bodyPr wrap="square" anchor="t" lIns="0" rIns="0" tIns="0" bIns="0">
             <a:spAutoFit/>
           </a:bodyPr>
@@ -6028,7 +6145,7 @@
       </p:sp>
       <p:sp>
         <p:nvSpPr>
-          <p:cNvPr id="9" name="TextBox 8"/>
+          <p:cNvPr id="12" name="TextBox 11"/>
           <p:cNvSpPr txBox="1"/>
           <p:nvPr/>
         </p:nvSpPr>

</xml_diff>

<commit_message>
Move the 'try it' QR to slide 3 (the demo slide)
Place the stable /app QR in the bottom-right of slide 3 alongside the live-demo
cue, and restore slide 5 to full-width bullets.

Co-Authored-By: Claude Opus 4.8 <noreply@anthropic.com>
</commit_message>
<xml_diff>
--- a/backend/docs/report/NinaivX-Presentation.pptx
+++ b/backend/docs/report/NinaivX-Presentation.pptx
@@ -4790,8 +4790,8 @@
         </p:blipFill>
         <p:spPr>
           <a:xfrm>
-            <a:off x="6400800" y="1388895"/>
-            <a:ext cx="5577840" cy="4445968"/>
+            <a:off x="7200013" y="1371600"/>
+            <a:ext cx="3613653" cy="2880360"/>
           </a:xfrm>
           <a:prstGeom prst="rect">
             <a:avLst/>
@@ -4941,18 +4941,18 @@
         </p:nvSpPr>
         <p:spPr>
           <a:xfrm>
-            <a:off x="548640" y="5669280"/>
-            <a:ext cx="5760720" cy="640080"/>
+            <a:off x="9464040" y="4434840"/>
+            <a:ext cx="2240280" cy="1737360"/>
           </a:xfrm>
           <a:prstGeom prst="roundRect">
             <a:avLst/>
           </a:prstGeom>
           <a:solidFill>
-            <a:srgbClr val="FEF3DF"/>
+            <a:srgbClr val="EEF4F3"/>
           </a:solidFill>
           <a:ln w="19050">
             <a:solidFill>
-              <a:srgbClr val="C97A1A"/>
+              <a:srgbClr val="2A6F6B"/>
             </a:solidFill>
           </a:ln>
           <a:effectLst/>
@@ -4979,16 +4979,40 @@
           </a:p>
         </p:txBody>
       </p:sp>
-      <p:sp>
-        <p:nvSpPr>
-          <p:cNvPr id="8" name="TextBox 7"/>
+      <p:pic>
+        <p:nvPicPr>
+          <p:cNvPr id="8" name="Picture 7" descr="qr-tryit.png"/>
+          <p:cNvPicPr>
+            <a:picLocks noChangeAspect="1"/>
+          </p:cNvPicPr>
+          <p:nvPr/>
+        </p:nvPicPr>
+        <p:blipFill>
+          <a:blip r:embed="rId3"/>
+          <a:stretch>
+            <a:fillRect/>
+          </a:stretch>
+        </p:blipFill>
+        <p:spPr>
+          <a:xfrm>
+            <a:off x="9966960" y="4572000"/>
+            <a:ext cx="1234440" cy="1234440"/>
+          </a:xfrm>
+          <a:prstGeom prst="rect">
+            <a:avLst/>
+          </a:prstGeom>
+        </p:spPr>
+      </p:pic>
+      <p:sp>
+        <p:nvSpPr>
+          <p:cNvPr id="9" name="TextBox 8"/>
           <p:cNvSpPr txBox="1"/>
           <p:nvPr/>
         </p:nvSpPr>
         <p:spPr>
           <a:xfrm>
-            <a:off x="640080" y="5669280"/>
-            <a:ext cx="5577840" cy="640080"/>
+            <a:off x="9464040" y="5742432"/>
+            <a:ext cx="2240280" cy="411480"/>
           </a:xfrm>
           <a:prstGeom prst="rect">
             <a:avLst/>
@@ -4996,34 +5020,80 @@
           <a:noFill/>
         </p:spPr>
         <p:txBody>
-          <a:bodyPr wrap="square" anchor="ctr" lIns="0" rIns="0" tIns="0" bIns="0">
+          <a:bodyPr wrap="square" anchor="t" lIns="0" rIns="0" tIns="0" bIns="0">
             <a:spAutoFit/>
           </a:bodyPr>
           <a:lstStyle/>
           <a:p>
-            <a:pPr algn="l"/>
-            <a:r>
-              <a:rPr sz="1400" b="1" i="0">
-                <a:solidFill>
-                  <a:srgbClr val="C97A1A"/>
+            <a:pPr algn="ctr"/>
+            <a:r>
+              <a:rPr sz="1100" b="1" i="0">
+                <a:solidFill>
+                  <a:srgbClr val="2A6F6B"/>
                 </a:solidFill>
                 <a:latin typeface="Segoe UI"/>
               </a:rPr>
-              <a:t>▶  LIVE DEMO  —  create a persona, then chat &amp; talk to it</a:t>
-            </a:r>
-          </a:p>
-        </p:txBody>
-      </p:sp>
-      <p:sp>
-        <p:nvSpPr>
-          <p:cNvPr id="9" name="TextBox 8"/>
+              <a:t>Scan to try it  (Expo Go)</a:t>
+            </a:r>
+          </a:p>
+        </p:txBody>
+      </p:sp>
+      <p:sp>
+        <p:nvSpPr>
+          <p:cNvPr id="10" name="Rounded Rectangle 9"/>
+          <p:cNvSpPr/>
+          <p:nvPr/>
+        </p:nvSpPr>
+        <p:spPr>
+          <a:xfrm>
+            <a:off x="548640" y="5669280"/>
+            <a:ext cx="5760720" cy="640080"/>
+          </a:xfrm>
+          <a:prstGeom prst="roundRect">
+            <a:avLst/>
+          </a:prstGeom>
+          <a:solidFill>
+            <a:srgbClr val="FEF3DF"/>
+          </a:solidFill>
+          <a:ln w="19050">
+            <a:solidFill>
+              <a:srgbClr val="C97A1A"/>
+            </a:solidFill>
+          </a:ln>
+          <a:effectLst/>
+        </p:spPr>
+        <p:style>
+          <a:lnRef idx="1">
+            <a:schemeClr val="accent1"/>
+          </a:lnRef>
+          <a:fillRef idx="3">
+            <a:schemeClr val="accent1"/>
+          </a:fillRef>
+          <a:effectRef idx="2">
+            <a:schemeClr val="accent1"/>
+          </a:effectRef>
+          <a:fontRef idx="minor">
+            <a:schemeClr val="lt1"/>
+          </a:fontRef>
+        </p:style>
+        <p:txBody>
+          <a:bodyPr rtlCol="0" anchor="ctr"/>
+          <a:lstStyle/>
+          <a:p>
+            <a:pPr algn="ctr"/>
+          </a:p>
+        </p:txBody>
+      </p:sp>
+      <p:sp>
+        <p:nvSpPr>
+          <p:cNvPr id="11" name="TextBox 10"/>
           <p:cNvSpPr txBox="1"/>
           <p:nvPr/>
         </p:nvSpPr>
         <p:spPr>
           <a:xfrm>
-            <a:off x="548640" y="6419088"/>
-            <a:ext cx="8229600" cy="320040"/>
+            <a:off x="640080" y="5669280"/>
+            <a:ext cx="5577840" cy="640080"/>
           </a:xfrm>
           <a:prstGeom prst="rect">
             <a:avLst/>
@@ -5031,6 +5101,41 @@
           <a:noFill/>
         </p:spPr>
         <p:txBody>
+          <a:bodyPr wrap="square" anchor="ctr" lIns="0" rIns="0" tIns="0" bIns="0">
+            <a:spAutoFit/>
+          </a:bodyPr>
+          <a:lstStyle/>
+          <a:p>
+            <a:pPr algn="l"/>
+            <a:r>
+              <a:rPr sz="1400" b="1" i="0">
+                <a:solidFill>
+                  <a:srgbClr val="C97A1A"/>
+                </a:solidFill>
+                <a:latin typeface="Segoe UI"/>
+              </a:rPr>
+              <a:t>▶  LIVE DEMO  —  create a persona, then chat &amp; talk to it</a:t>
+            </a:r>
+          </a:p>
+        </p:txBody>
+      </p:sp>
+      <p:sp>
+        <p:nvSpPr>
+          <p:cNvPr id="12" name="TextBox 11"/>
+          <p:cNvSpPr txBox="1"/>
+          <p:nvPr/>
+        </p:nvSpPr>
+        <p:spPr>
+          <a:xfrm>
+            <a:off x="548640" y="6419088"/>
+            <a:ext cx="8229600" cy="320040"/>
+          </a:xfrm>
+          <a:prstGeom prst="rect">
+            <a:avLst/>
+          </a:prstGeom>
+          <a:noFill/>
+        </p:spPr>
+        <p:txBody>
           <a:bodyPr wrap="square" anchor="t" lIns="0" rIns="0" tIns="0" bIns="0">
             <a:spAutoFit/>
           </a:bodyPr>
@@ -5051,7 +5156,7 @@
       </p:sp>
       <p:sp>
         <p:nvSpPr>
-          <p:cNvPr id="10" name="TextBox 9"/>
+          <p:cNvPr id="13" name="TextBox 12"/>
           <p:cNvSpPr txBox="1"/>
           <p:nvPr/>
         </p:nvSpPr>
@@ -5784,7 +5889,7 @@
         <p:spPr>
           <a:xfrm>
             <a:off x="594360" y="1600200"/>
-            <a:ext cx="8138160" cy="4754880"/>
+            <a:ext cx="10972800" cy="4754880"/>
           </a:xfrm>
           <a:prstGeom prst="rect">
             <a:avLst/>
@@ -5918,14 +6023,14 @@
         </p:nvSpPr>
         <p:spPr>
           <a:xfrm>
-            <a:off x="9189720" y="1554480"/>
-            <a:ext cx="2514600" cy="3108960"/>
+            <a:off x="594360" y="5257800"/>
+            <a:ext cx="10972800" cy="914400"/>
           </a:xfrm>
           <a:prstGeom prst="roundRect">
             <a:avLst/>
           </a:prstGeom>
           <a:solidFill>
-            <a:srgbClr val="EEF4F3"/>
+            <a:srgbClr val="2A6F6B"/>
           </a:solidFill>
           <a:ln w="19050">
             <a:solidFill>
@@ -5956,40 +6061,16 @@
           </a:p>
         </p:txBody>
       </p:sp>
-      <p:pic>
-        <p:nvPicPr>
-          <p:cNvPr id="7" name="Picture 6" descr="qr-tryit.png"/>
-          <p:cNvPicPr>
-            <a:picLocks noChangeAspect="1"/>
-          </p:cNvPicPr>
-          <p:nvPr/>
-        </p:nvPicPr>
-        <p:blipFill>
-          <a:blip r:embed="rId2"/>
-          <a:stretch>
-            <a:fillRect/>
-          </a:stretch>
-        </p:blipFill>
-        <p:spPr>
-          <a:xfrm>
-            <a:off x="9326880" y="1737360"/>
-            <a:ext cx="2240280" cy="2240280"/>
-          </a:xfrm>
-          <a:prstGeom prst="rect">
-            <a:avLst/>
-          </a:prstGeom>
-        </p:spPr>
-      </p:pic>
-      <p:sp>
-        <p:nvSpPr>
-          <p:cNvPr id="8" name="TextBox 7"/>
+      <p:sp>
+        <p:nvSpPr>
+          <p:cNvPr id="7" name="TextBox 6"/>
           <p:cNvSpPr txBox="1"/>
           <p:nvPr/>
         </p:nvSpPr>
         <p:spPr>
           <a:xfrm>
-            <a:off x="9235440" y="4023360"/>
-            <a:ext cx="2423160" cy="731520"/>
+            <a:off x="594360" y="5257800"/>
+            <a:ext cx="10972800" cy="914400"/>
           </a:xfrm>
           <a:prstGeom prst="rect">
             <a:avLst/>
@@ -5997,92 +6078,34 @@
           <a:noFill/>
         </p:spPr>
         <p:txBody>
-          <a:bodyPr wrap="square" anchor="t" lIns="0" rIns="0" tIns="0" bIns="0">
+          <a:bodyPr wrap="square" anchor="ctr" lIns="0" rIns="0" tIns="0" bIns="0">
             <a:spAutoFit/>
           </a:bodyPr>
           <a:lstStyle/>
           <a:p>
             <a:pPr algn="ctr"/>
             <a:r>
-              <a:rPr sz="1300" b="1" i="0">
-                <a:solidFill>
-                  <a:srgbClr val="2A6F6B"/>
+              <a:rPr sz="2600" b="1" i="0">
+                <a:solidFill>
+                  <a:srgbClr val="FFFFFF"/>
                 </a:solidFill>
                 <a:latin typeface="Segoe UI"/>
               </a:rPr>
-              <a:t>Scan to try it</a:t>
-            </a:r>
-          </a:p>
-          <a:p>
-            <a:pPr algn="ctr"/>
-            <a:r>
-              <a:rPr sz="1050" b="0" i="0">
-                <a:solidFill>
-                  <a:srgbClr val="444E57"/>
-                </a:solidFill>
-                <a:latin typeface="Segoe UI"/>
-              </a:rPr>
-              <a:t>(free Expo Go app)</a:t>
-            </a:r>
-          </a:p>
-        </p:txBody>
-      </p:sp>
-      <p:sp>
-        <p:nvSpPr>
-          <p:cNvPr id="9" name="Rounded Rectangle 8"/>
-          <p:cNvSpPr/>
-          <p:nvPr/>
-        </p:nvSpPr>
-        <p:spPr>
-          <a:xfrm>
-            <a:off x="594360" y="5257800"/>
-            <a:ext cx="10972800" cy="914400"/>
-          </a:xfrm>
-          <a:prstGeom prst="roundRect">
-            <a:avLst/>
-          </a:prstGeom>
-          <a:solidFill>
-            <a:srgbClr val="2A6F6B"/>
-          </a:solidFill>
-          <a:ln w="19050">
-            <a:solidFill>
-              <a:srgbClr val="2A6F6B"/>
-            </a:solidFill>
-          </a:ln>
-          <a:effectLst/>
-        </p:spPr>
-        <p:style>
-          <a:lnRef idx="1">
-            <a:schemeClr val="accent1"/>
-          </a:lnRef>
-          <a:fillRef idx="3">
-            <a:schemeClr val="accent1"/>
-          </a:fillRef>
-          <a:effectRef idx="2">
-            <a:schemeClr val="accent1"/>
-          </a:effectRef>
-          <a:fontRef idx="minor">
-            <a:schemeClr val="lt1"/>
-          </a:fontRef>
-        </p:style>
-        <p:txBody>
-          <a:bodyPr rtlCol="0" anchor="ctr"/>
-          <a:lstStyle/>
-          <a:p>
-            <a:pPr algn="ctr"/>
-          </a:p>
-        </p:txBody>
-      </p:sp>
-      <p:sp>
-        <p:nvSpPr>
-          <p:cNvPr id="10" name="TextBox 9"/>
+              <a:t>Thank you  —  questions?</a:t>
+            </a:r>
+          </a:p>
+        </p:txBody>
+      </p:sp>
+      <p:sp>
+        <p:nvSpPr>
+          <p:cNvPr id="8" name="TextBox 7"/>
           <p:cNvSpPr txBox="1"/>
           <p:nvPr/>
         </p:nvSpPr>
         <p:spPr>
           <a:xfrm>
-            <a:off x="594360" y="5257800"/>
-            <a:ext cx="10972800" cy="914400"/>
+            <a:off x="548640" y="6419088"/>
+            <a:ext cx="8229600" cy="320040"/>
           </a:xfrm>
           <a:prstGeom prst="rect">
             <a:avLst/>
@@ -6090,41 +6113,6 @@
           <a:noFill/>
         </p:spPr>
         <p:txBody>
-          <a:bodyPr wrap="square" anchor="ctr" lIns="0" rIns="0" tIns="0" bIns="0">
-            <a:spAutoFit/>
-          </a:bodyPr>
-          <a:lstStyle/>
-          <a:p>
-            <a:pPr algn="ctr"/>
-            <a:r>
-              <a:rPr sz="2600" b="1" i="0">
-                <a:solidFill>
-                  <a:srgbClr val="FFFFFF"/>
-                </a:solidFill>
-                <a:latin typeface="Segoe UI"/>
-              </a:rPr>
-              <a:t>Thank you  —  questions?</a:t>
-            </a:r>
-          </a:p>
-        </p:txBody>
-      </p:sp>
-      <p:sp>
-        <p:nvSpPr>
-          <p:cNvPr id="11" name="TextBox 10"/>
-          <p:cNvSpPr txBox="1"/>
-          <p:nvPr/>
-        </p:nvSpPr>
-        <p:spPr>
-          <a:xfrm>
-            <a:off x="548640" y="6419088"/>
-            <a:ext cx="8229600" cy="320040"/>
-          </a:xfrm>
-          <a:prstGeom prst="rect">
-            <a:avLst/>
-          </a:prstGeom>
-          <a:noFill/>
-        </p:spPr>
-        <p:txBody>
           <a:bodyPr wrap="square" anchor="t" lIns="0" rIns="0" tIns="0" bIns="0">
             <a:spAutoFit/>
           </a:bodyPr>
@@ -6145,7 +6133,7 @@
       </p:sp>
       <p:sp>
         <p:nvSpPr>
-          <p:cNvPr id="12" name="TextBox 11"/>
+          <p:cNvPr id="9" name="TextBox 8"/>
           <p:cNvSpPr txBox="1"/>
           <p:nvPr/>
         </p:nvSpPr>

</xml_diff>

<commit_message>
Add backup slide: research gaps -> how NinaivX addresses them
Slide 6 is a Q&A backup (not for the main talk): a 9-row table mapping each
literature gap (G1-G9) to how NinaivX addresses it, so the gap-vs-research-question
question can be answered visually. Notes mark it as backup-only.

Co-Authored-By: Claude Opus 4.8 <noreply@anthropic.com>
Claude-Session: https://claude.ai/code/session_01NdSzTk1rMfZ8qJXjYpCNwm
</commit_message>
<xml_diff>
--- a/backend/docs/report/NinaivX-Presentation.pptx
+++ b/backend/docs/report/NinaivX-Presentation.pptx
@@ -10,6 +10,7 @@
     <p:sldId id="258" r:id="rId10"/>
     <p:sldId id="259" r:id="rId11"/>
     <p:sldId id="260" r:id="rId12"/>
+    <p:sldId id="261" r:id="rId13"/>
   </p:sldIdLst>
   <p:sldSz cx="12191695" cy="6858000" type="screen4x3"/>
   <p:notesSz cx="6858000" cy="9144000"/>
@@ -799,6 +800,76 @@
           <a:p>
             <a:r>
               <a:t>VIVA QUICK FACTS: Claude Sonnet on AWS Bedrock (EU); FastAPI+LangGraph, Supabase, ElevenLabs, React Native/Expo. Air-gap = deceased node binds no tools (code-level). Hallucination 83-&gt;25% overall, post-death 100-&gt;0% (declined every one). Study n=21, 4.6/5. Deterministic router so routing can't be manipulated. Ethics ref 076699. Main limitation: personal-fact confabulation -&gt; fix with RAG.</a:t>
+            </a:r>
+          </a:p>
+        </p:txBody>
+      </p:sp>
+      <p:sp>
+        <p:nvSpPr>
+          <p:cNvPr id="4" name="Slide Number Placeholder 3"/>
+          <p:cNvSpPr>
+            <a:spLocks noGrp="1"/>
+          </p:cNvSpPr>
+          <p:nvPr>
+            <p:ph type="sldNum" idx="5" sz="quarter"/>
+          </p:nvPr>
+        </p:nvSpPr>
+        <p:spPr/>
+      </p:sp>
+    </p:spTree>
+  </p:cSld>
+  <p:clrMapOvr>
+    <a:masterClrMapping/>
+  </p:clrMapOvr>
+</p:notes>
+</file>
+
+<file path=ppt/notesSlides/notesSlide6.xml><?xml version="1.0" encoding="utf-8"?>
+<p:notes xmlns:a="http://schemas.openxmlformats.org/drawingml/2006/main" xmlns:p="http://schemas.openxmlformats.org/presentationml/2006/main" xmlns:r="http://schemas.openxmlformats.org/officeDocument/2006/relationships">
+  <p:cSld>
+    <p:spTree>
+      <p:nvGrpSpPr>
+        <p:cNvPr id="1" name=""/>
+        <p:cNvGrpSpPr/>
+        <p:nvPr/>
+      </p:nvGrpSpPr>
+      <p:grpSpPr>
+        <a:xfrm>
+          <a:off x="0" y="0"/>
+          <a:ext cx="0" cy="0"/>
+          <a:chOff x="0" y="0"/>
+          <a:chExt cx="0" cy="0"/>
+        </a:xfrm>
+      </p:grpSpPr>
+      <p:sp>
+        <p:nvSpPr>
+          <p:cNvPr id="2" name="Slide Image Placeholder 1"/>
+          <p:cNvSpPr>
+            <a:spLocks noGrp="1"/>
+          </p:cNvSpPr>
+          <p:nvPr>
+            <p:ph type="sldImg" idx="2"/>
+          </p:nvPr>
+        </p:nvSpPr>
+        <p:spPr/>
+      </p:sp>
+      <p:sp>
+        <p:nvSpPr>
+          <p:cNvPr id="3" name="Notes Placeholder 2"/>
+          <p:cNvSpPr>
+            <a:spLocks noGrp="1"/>
+          </p:cNvSpPr>
+          <p:nvPr>
+            <p:ph type="body" idx="3" sz="quarter"/>
+          </p:nvPr>
+        </p:nvSpPr>
+        <p:spPr/>
+        <p:txBody>
+          <a:bodyPr/>
+          <a:lstStyle/>
+          <a:p>
+            <a:r>
+              <a:t>BACKUP SLIDE — do not present unless asked. If a marker asks 'how does this address the gaps you found?', show this. Key line: every gap is addressed — most by design/requirements, and the two open, testable ones (hallucination G3 and dual-mode G9) became my research questions RQ1 and RQ2.</a:t>
             </a:r>
           </a:p>
         </p:txBody>
@@ -6162,6 +6233,738 @@
                 <a:latin typeface="Segoe UI"/>
               </a:rPr>
               <a:t>5</a:t>
+            </a:r>
+          </a:p>
+        </p:txBody>
+      </p:sp>
+    </p:spTree>
+  </p:cSld>
+  <p:clrMapOvr>
+    <a:masterClrMapping/>
+  </p:clrMapOvr>
+</p:sld>
+</file>
+
+<file path=ppt/slides/slide6.xml><?xml version="1.0" encoding="utf-8"?>
+<p:sld xmlns:a="http://schemas.openxmlformats.org/drawingml/2006/main" xmlns:p="http://schemas.openxmlformats.org/presentationml/2006/main" xmlns:r="http://schemas.openxmlformats.org/officeDocument/2006/relationships">
+  <p:cSld>
+    <p:spTree>
+      <p:nvGrpSpPr>
+        <p:cNvPr id="1" name=""/>
+        <p:cNvGrpSpPr/>
+        <p:nvPr/>
+      </p:nvGrpSpPr>
+      <p:grpSpPr/>
+      <p:sp>
+        <p:nvSpPr>
+          <p:cNvPr id="2" name="Rectangle 1"/>
+          <p:cNvSpPr/>
+          <p:nvPr/>
+        </p:nvSpPr>
+        <p:spPr>
+          <a:xfrm>
+            <a:off x="0" y="0"/>
+            <a:ext cx="12191695" cy="146304"/>
+          </a:xfrm>
+          <a:prstGeom prst="rect">
+            <a:avLst/>
+          </a:prstGeom>
+          <a:solidFill>
+            <a:srgbClr val="2A6F6B"/>
+          </a:solidFill>
+          <a:ln>
+            <a:noFill/>
+          </a:ln>
+          <a:effectLst/>
+        </p:spPr>
+        <p:style>
+          <a:lnRef idx="1">
+            <a:schemeClr val="accent1"/>
+          </a:lnRef>
+          <a:fillRef idx="3">
+            <a:schemeClr val="accent1"/>
+          </a:fillRef>
+          <a:effectRef idx="2">
+            <a:schemeClr val="accent1"/>
+          </a:effectRef>
+          <a:fontRef idx="minor">
+            <a:schemeClr val="lt1"/>
+          </a:fontRef>
+        </p:style>
+        <p:txBody>
+          <a:bodyPr rtlCol="0" anchor="ctr"/>
+          <a:lstStyle/>
+          <a:p>
+            <a:pPr algn="ctr"/>
+          </a:p>
+        </p:txBody>
+      </p:sp>
+      <p:sp>
+        <p:nvSpPr>
+          <p:cNvPr id="3" name="TextBox 2"/>
+          <p:cNvSpPr txBox="1"/>
+          <p:nvPr/>
+        </p:nvSpPr>
+        <p:spPr>
+          <a:xfrm>
+            <a:off x="548640" y="384048"/>
+            <a:ext cx="11064240" cy="822960"/>
+          </a:xfrm>
+          <a:prstGeom prst="rect">
+            <a:avLst/>
+          </a:prstGeom>
+          <a:noFill/>
+        </p:spPr>
+        <p:txBody>
+          <a:bodyPr wrap="square" anchor="t" lIns="0" rIns="0" tIns="0" bIns="0">
+            <a:spAutoFit/>
+          </a:bodyPr>
+          <a:lstStyle/>
+          <a:p>
+            <a:pPr algn="l"/>
+            <a:r>
+              <a:rPr sz="3000" b="1" i="0">
+                <a:solidFill>
+                  <a:srgbClr val="2A6F6B"/>
+                </a:solidFill>
+                <a:latin typeface="Segoe UI"/>
+              </a:rPr>
+              <a:t>Research gaps → how NinaivX addresses them</a:t>
+            </a:r>
+          </a:p>
+        </p:txBody>
+      </p:sp>
+      <p:sp>
+        <p:nvSpPr>
+          <p:cNvPr id="4" name="Rectangle 3"/>
+          <p:cNvSpPr/>
+          <p:nvPr/>
+        </p:nvSpPr>
+        <p:spPr>
+          <a:xfrm>
+            <a:off x="566928" y="1170432"/>
+            <a:ext cx="2926080" cy="41148"/>
+          </a:xfrm>
+          <a:prstGeom prst="rect">
+            <a:avLst/>
+          </a:prstGeom>
+          <a:solidFill>
+            <a:srgbClr val="C97A1A"/>
+          </a:solidFill>
+          <a:ln>
+            <a:noFill/>
+          </a:ln>
+          <a:effectLst/>
+        </p:spPr>
+        <p:style>
+          <a:lnRef idx="1">
+            <a:schemeClr val="accent1"/>
+          </a:lnRef>
+          <a:fillRef idx="3">
+            <a:schemeClr val="accent1"/>
+          </a:fillRef>
+          <a:effectRef idx="2">
+            <a:schemeClr val="accent1"/>
+          </a:effectRef>
+          <a:fontRef idx="minor">
+            <a:schemeClr val="lt1"/>
+          </a:fontRef>
+        </p:style>
+        <p:txBody>
+          <a:bodyPr rtlCol="0" anchor="ctr"/>
+          <a:lstStyle/>
+          <a:p>
+            <a:pPr algn="ctr"/>
+          </a:p>
+        </p:txBody>
+      </p:sp>
+      <p:sp>
+        <p:nvSpPr>
+          <p:cNvPr id="5" name="TextBox 4"/>
+          <p:cNvSpPr txBox="1"/>
+          <p:nvPr/>
+        </p:nvSpPr>
+        <p:spPr>
+          <a:xfrm>
+            <a:off x="566928" y="1243584"/>
+            <a:ext cx="10972800" cy="457200"/>
+          </a:xfrm>
+          <a:prstGeom prst="rect">
+            <a:avLst/>
+          </a:prstGeom>
+          <a:noFill/>
+        </p:spPr>
+        <p:txBody>
+          <a:bodyPr wrap="square" anchor="t" lIns="0" rIns="0" tIns="0" bIns="0">
+            <a:spAutoFit/>
+          </a:bodyPr>
+          <a:lstStyle/>
+          <a:p>
+            <a:pPr algn="l"/>
+            <a:r>
+              <a:rPr sz="1500" b="0" i="1">
+                <a:solidFill>
+                  <a:srgbClr val="444E57"/>
+                </a:solidFill>
+                <a:latin typeface="Segoe UI"/>
+              </a:rPr>
+              <a:t>Backup slide — for questions</a:t>
+            </a:r>
+          </a:p>
+        </p:txBody>
+      </p:sp>
+      <p:graphicFrame>
+        <p:nvGraphicFramePr>
+          <p:cNvPr id="6" name="Table 5"/>
+          <p:cNvGraphicFramePr>
+            <a:graphicFrameLocks noGrp="1"/>
+          </p:cNvGraphicFramePr>
+          <p:nvPr/>
+        </p:nvGraphicFramePr>
+        <p:xfrm>
+          <a:off x="457200" y="1417320"/>
+          <a:ext cx="11274552" cy="4663440"/>
+        </p:xfrm>
+        <a:graphic>
+          <a:graphicData uri="http://schemas.openxmlformats.org/drawingml/2006/table">
+            <a:tbl>
+              <a:tblPr firstRow="1" bandRow="1">
+                <a:tableStyleId>{5C22544A-7EE6-4342-B048-85BDC9FD1C3A}</a:tableStyleId>
+              </a:tblPr>
+              <a:tblGrid>
+                <a:gridCol w="4937760"/>
+                <a:gridCol w="6336792"/>
+              </a:tblGrid>
+              <a:tr h="466344">
+                <a:tc>
+                  <a:txBody>
+                    <a:bodyPr wrap="square"/>
+                    <a:lstStyle/>
+                    <a:p>
+                      <a:r>
+                        <a:rPr sz="1200" b="1">
+                          <a:solidFill>
+                            <a:srgbClr val="FFFFFF"/>
+                          </a:solidFill>
+                          <a:latin typeface="Segoe UI"/>
+                        </a:rPr>
+                        <a:t>Gap in existing systems</a:t>
+                      </a:r>
+                    </a:p>
+                  </a:txBody>
+                  <a:tcPr marL="73152" marR="54864" marT="18288" marB="18288" anchor="ctr">
+                    <a:solidFill>
+                      <a:srgbClr val="2A6F6B"/>
+                    </a:solidFill>
+                  </a:tcPr>
+                </a:tc>
+                <a:tc>
+                  <a:txBody>
+                    <a:bodyPr wrap="square"/>
+                    <a:lstStyle/>
+                    <a:p>
+                      <a:r>
+                        <a:rPr sz="1200" b="1">
+                          <a:solidFill>
+                            <a:srgbClr val="FFFFFF"/>
+                          </a:solidFill>
+                          <a:latin typeface="Segoe UI"/>
+                        </a:rPr>
+                        <a:t>How NinaivX addresses it</a:t>
+                      </a:r>
+                    </a:p>
+                  </a:txBody>
+                  <a:tcPr marL="73152" marR="54864" marT="18288" marB="18288" anchor="ctr">
+                    <a:solidFill>
+                      <a:srgbClr val="2A6F6B"/>
+                    </a:solidFill>
+                  </a:tcPr>
+                </a:tc>
+              </a:tr>
+              <a:tr h="466344">
+                <a:tc>
+                  <a:txBody>
+                    <a:bodyPr wrap="square"/>
+                    <a:lstStyle/>
+                    <a:p>
+                      <a:r>
+                        <a:rPr sz="1100" b="1">
+                          <a:solidFill>
+                            <a:srgbClr val="222B33"/>
+                          </a:solidFill>
+                          <a:latin typeface="Segoe UI"/>
+                        </a:rPr>
+                        <a:t>G1  Static memorials only replay recordings — can’t converse</a:t>
+                      </a:r>
+                    </a:p>
+                  </a:txBody>
+                  <a:tcPr marL="73152" marR="54864" marT="18288" marB="18288" anchor="ctr">
+                    <a:solidFill>
+                      <a:srgbClr val="F2F8F7"/>
+                    </a:solidFill>
+                  </a:tcPr>
+                </a:tc>
+                <a:tc>
+                  <a:txBody>
+                    <a:bodyPr wrap="square"/>
+                    <a:lstStyle/>
+                    <a:p>
+                      <a:r>
+                        <a:rPr sz="1100" b="0">
+                          <a:solidFill>
+                            <a:srgbClr val="222B33"/>
+                          </a:solidFill>
+                          <a:latin typeface="Segoe UI"/>
+                        </a:rPr>
+                        <a:t>Generative conversation with persistent memory</a:t>
+                      </a:r>
+                    </a:p>
+                  </a:txBody>
+                  <a:tcPr marL="73152" marR="54864" marT="18288" marB="18288" anchor="ctr">
+                    <a:solidFill>
+                      <a:srgbClr val="F2F8F7"/>
+                    </a:solidFill>
+                  </a:tcPr>
+                </a:tc>
+              </a:tr>
+              <a:tr h="466344">
+                <a:tc>
+                  <a:txBody>
+                    <a:bodyPr wrap="square"/>
+                    <a:lstStyle/>
+                    <a:p>
+                      <a:r>
+                        <a:rPr sz="1100" b="1">
+                          <a:solidFill>
+                            <a:srgbClr val="222B33"/>
+                          </a:solidFill>
+                          <a:latin typeface="Segoe UI"/>
+                        </a:rPr>
+                        <a:t>G2  Griefbots are text-only, no natural voice</a:t>
+                      </a:r>
+                    </a:p>
+                  </a:txBody>
+                  <a:tcPr marL="73152" marR="54864" marT="18288" marB="18288" anchor="ctr">
+                    <a:solidFill>
+                      <a:srgbClr val="FFFFFF"/>
+                    </a:solidFill>
+                  </a:tcPr>
+                </a:tc>
+                <a:tc>
+                  <a:txBody>
+                    <a:bodyPr wrap="square"/>
+                    <a:lstStyle/>
+                    <a:p>
+                      <a:r>
+                        <a:rPr sz="1100" b="0">
+                          <a:solidFill>
+                            <a:srgbClr val="222B33"/>
+                          </a:solidFill>
+                          <a:latin typeface="Segoe UI"/>
+                        </a:rPr>
+                        <a:t>Full voice loop (speech → AI → speech) + cloning</a:t>
+                      </a:r>
+                    </a:p>
+                  </a:txBody>
+                  <a:tcPr marL="73152" marR="54864" marT="18288" marB="18288" anchor="ctr">
+                    <a:solidFill>
+                      <a:srgbClr val="FFFFFF"/>
+                    </a:solidFill>
+                  </a:tcPr>
+                </a:tc>
+              </a:tr>
+              <a:tr h="466344">
+                <a:tc>
+                  <a:txBody>
+                    <a:bodyPr wrap="square"/>
+                    <a:lstStyle/>
+                    <a:p>
+                      <a:r>
+                        <a:rPr sz="1100" b="1">
+                          <a:solidFill>
+                            <a:srgbClr val="222B33"/>
+                          </a:solidFill>
+                          <a:latin typeface="Segoe UI"/>
+                        </a:rPr>
+                        <a:t>G3  Models hallucinate about the real person</a:t>
+                      </a:r>
+                    </a:p>
+                  </a:txBody>
+                  <a:tcPr marL="73152" marR="54864" marT="18288" marB="18288" anchor="ctr">
+                    <a:solidFill>
+                      <a:srgbClr val="F2F8F7"/>
+                    </a:solidFill>
+                  </a:tcPr>
+                </a:tc>
+                <a:tc>
+                  <a:txBody>
+                    <a:bodyPr wrap="square"/>
+                    <a:lstStyle/>
+                    <a:p>
+                      <a:r>
+                        <a:rPr sz="1100" b="0">
+                          <a:solidFill>
+                            <a:srgbClr val="222B33"/>
+                          </a:solidFill>
+                          <a:latin typeface="Segoe UI"/>
+                        </a:rPr>
+                        <a:t>Air-gap + temporal grounding (83→25%; post-death 100→0%)</a:t>
+                      </a:r>
+                    </a:p>
+                  </a:txBody>
+                  <a:tcPr marL="73152" marR="54864" marT="18288" marB="18288" anchor="ctr">
+                    <a:solidFill>
+                      <a:srgbClr val="F2F8F7"/>
+                    </a:solidFill>
+                  </a:tcPr>
+                </a:tc>
+              </a:tr>
+              <a:tr h="466344">
+                <a:tc>
+                  <a:txBody>
+                    <a:bodyPr wrap="square"/>
+                    <a:lstStyle/>
+                    <a:p>
+                      <a:r>
+                        <a:rPr sz="1100" b="1">
+                          <a:solidFill>
+                            <a:srgbClr val="222B33"/>
+                          </a:solidFill>
+                          <a:latin typeface="Segoe UI"/>
+                        </a:rPr>
+                        <a:t>G4  No AI-transparency disclosure</a:t>
+                      </a:r>
+                    </a:p>
+                  </a:txBody>
+                  <a:tcPr marL="73152" marR="54864" marT="18288" marB="18288" anchor="ctr">
+                    <a:solidFill>
+                      <a:srgbClr val="FFFFFF"/>
+                    </a:solidFill>
+                  </a:tcPr>
+                </a:tc>
+                <a:tc>
+                  <a:txBody>
+                    <a:bodyPr wrap="square"/>
+                    <a:lstStyle/>
+                    <a:p>
+                      <a:r>
+                        <a:rPr sz="1100" b="0">
+                          <a:solidFill>
+                            <a:srgbClr val="222B33"/>
+                          </a:solidFill>
+                          <a:latin typeface="Segoe UI"/>
+                        </a:rPr>
+                        <a:t>Discloses it is an AI; notice each session</a:t>
+                      </a:r>
+                    </a:p>
+                  </a:txBody>
+                  <a:tcPr marL="73152" marR="54864" marT="18288" marB="18288" anchor="ctr">
+                    <a:solidFill>
+                      <a:srgbClr val="FFFFFF"/>
+                    </a:solidFill>
+                  </a:tcPr>
+                </a:tc>
+              </a:tr>
+              <a:tr h="466344">
+                <a:tc>
+                  <a:txBody>
+                    <a:bodyPr wrap="square"/>
+                    <a:lstStyle/>
+                    <a:p>
+                      <a:r>
+                        <a:rPr sz="1100" b="1">
+                          <a:solidFill>
+                            <a:srgbClr val="222B33"/>
+                          </a:solidFill>
+                          <a:latin typeface="Segoe UI"/>
+                        </a:rPr>
+                        <a:t>G5  Engagement-driven design fosters dependency</a:t>
+                      </a:r>
+                    </a:p>
+                  </a:txBody>
+                  <a:tcPr marL="73152" marR="54864" marT="18288" marB="18288" anchor="ctr">
+                    <a:solidFill>
+                      <a:srgbClr val="F2F8F7"/>
+                    </a:solidFill>
+                  </a:tcPr>
+                </a:tc>
+                <a:tc>
+                  <a:txBody>
+                    <a:bodyPr wrap="square"/>
+                    <a:lstStyle/>
+                    <a:p>
+                      <a:r>
+                        <a:rPr sz="1100" b="0">
+                          <a:solidFill>
+                            <a:srgbClr val="222B33"/>
+                          </a:solidFill>
+                          <a:latin typeface="Segoe UI"/>
+                        </a:rPr>
+                        <a:t>No gamification; designed for grief &amp; closure</a:t>
+                      </a:r>
+                    </a:p>
+                  </a:txBody>
+                  <a:tcPr marL="73152" marR="54864" marT="18288" marB="18288" anchor="ctr">
+                    <a:solidFill>
+                      <a:srgbClr val="F2F8F7"/>
+                    </a:solidFill>
+                  </a:tcPr>
+                </a:tc>
+              </a:tr>
+              <a:tr h="466344">
+                <a:tc>
+                  <a:txBody>
+                    <a:bodyPr wrap="square"/>
+                    <a:lstStyle/>
+                    <a:p>
+                      <a:r>
+                        <a:rPr sz="1100" b="1">
+                          <a:solidFill>
+                            <a:srgbClr val="222B33"/>
+                          </a:solidFill>
+                          <a:latin typeface="Segoe UI"/>
+                        </a:rPr>
+                        <a:t>G6  Sensitive data handled opaquely</a:t>
+                      </a:r>
+                    </a:p>
+                  </a:txBody>
+                  <a:tcPr marL="73152" marR="54864" marT="18288" marB="18288" anchor="ctr">
+                    <a:solidFill>
+                      <a:srgbClr val="FFFFFF"/>
+                    </a:solidFill>
+                  </a:tcPr>
+                </a:tc>
+                <a:tc>
+                  <a:txBody>
+                    <a:bodyPr wrap="square"/>
+                    <a:lstStyle/>
+                    <a:p>
+                      <a:r>
+                        <a:rPr sz="1100" b="0">
+                          <a:solidFill>
+                            <a:srgbClr val="222B33"/>
+                          </a:solidFill>
+                          <a:latin typeface="Segoe UI"/>
+                        </a:rPr>
+                        <a:t>Per-user isolation, auth, summary-only memory, synthetic voices</a:t>
+                      </a:r>
+                    </a:p>
+                  </a:txBody>
+                  <a:tcPr marL="73152" marR="54864" marT="18288" marB="18288" anchor="ctr">
+                    <a:solidFill>
+                      <a:srgbClr val="FFFFFF"/>
+                    </a:solidFill>
+                  </a:tcPr>
+                </a:tc>
+              </a:tr>
+              <a:tr h="466344">
+                <a:tc>
+                  <a:txBody>
+                    <a:bodyPr wrap="square"/>
+                    <a:lstStyle/>
+                    <a:p>
+                      <a:r>
+                        <a:rPr sz="1100" b="1">
+                          <a:solidFill>
+                            <a:srgbClr val="222B33"/>
+                          </a:solidFill>
+                          <a:latin typeface="Segoe UI"/>
+                        </a:rPr>
+                        <a:t>G7  Closed, proprietary; not reproducible</a:t>
+                      </a:r>
+                    </a:p>
+                  </a:txBody>
+                  <a:tcPr marL="73152" marR="54864" marT="18288" marB="18288" anchor="ctr">
+                    <a:solidFill>
+                      <a:srgbClr val="F2F8F7"/>
+                    </a:solidFill>
+                  </a:tcPr>
+                </a:tc>
+                <a:tc>
+                  <a:txBody>
+                    <a:bodyPr wrap="square"/>
+                    <a:lstStyle/>
+                    <a:p>
+                      <a:r>
+                        <a:rPr sz="1100" b="0">
+                          <a:solidFill>
+                            <a:srgbClr val="222B33"/>
+                          </a:solidFill>
+                          <a:latin typeface="Segoe UI"/>
+                        </a:rPr>
+                        <a:t>Openly documented, reproducible architecture</a:t>
+                      </a:r>
+                    </a:p>
+                  </a:txBody>
+                  <a:tcPr marL="73152" marR="54864" marT="18288" marB="18288" anchor="ctr">
+                    <a:solidFill>
+                      <a:srgbClr val="F2F8F7"/>
+                    </a:solidFill>
+                  </a:tcPr>
+                </a:tc>
+              </a:tr>
+              <a:tr h="466344">
+                <a:tc>
+                  <a:txBody>
+                    <a:bodyPr wrap="square"/>
+                    <a:lstStyle/>
+                    <a:p>
+                      <a:r>
+                        <a:rPr sz="1100" b="1">
+                          <a:solidFill>
+                            <a:srgbClr val="222B33"/>
+                          </a:solidFill>
+                          <a:latin typeface="Segoe UI"/>
+                        </a:rPr>
+                        <a:t>G8  No published evaluation</a:t>
+                      </a:r>
+                    </a:p>
+                  </a:txBody>
+                  <a:tcPr marL="73152" marR="54864" marT="18288" marB="18288" anchor="ctr">
+                    <a:solidFill>
+                      <a:srgbClr val="FFFFFF"/>
+                    </a:solidFill>
+                  </a:tcPr>
+                </a:tc>
+                <a:tc>
+                  <a:txBody>
+                    <a:bodyPr wrap="square"/>
+                    <a:lstStyle/>
+                    <a:p>
+                      <a:r>
+                        <a:rPr sz="1100" b="0">
+                          <a:solidFill>
+                            <a:srgbClr val="222B33"/>
+                          </a:solidFill>
+                          <a:latin typeface="Segoe UI"/>
+                        </a:rPr>
+                        <a:t>User study (n=21) + controlled hallucination experiment</a:t>
+                      </a:r>
+                    </a:p>
+                  </a:txBody>
+                  <a:tcPr marL="73152" marR="54864" marT="18288" marB="18288" anchor="ctr">
+                    <a:solidFill>
+                      <a:srgbClr val="FFFFFF"/>
+                    </a:solidFill>
+                  </a:tcPr>
+                </a:tc>
+              </a:tr>
+              <a:tr h="466344">
+                <a:tc>
+                  <a:txBody>
+                    <a:bodyPr wrap="square"/>
+                    <a:lstStyle/>
+                    <a:p>
+                      <a:r>
+                        <a:rPr sz="1100" b="1">
+                          <a:solidFill>
+                            <a:srgbClr val="222B33"/>
+                          </a:solidFill>
+                          <a:latin typeface="Segoe UI"/>
+                        </a:rPr>
+                        <a:t>G9  Deceased-only; no companion mode</a:t>
+                      </a:r>
+                    </a:p>
+                  </a:txBody>
+                  <a:tcPr marL="73152" marR="54864" marT="18288" marB="18288" anchor="ctr">
+                    <a:solidFill>
+                      <a:srgbClr val="F2F8F7"/>
+                    </a:solidFill>
+                  </a:tcPr>
+                </a:tc>
+                <a:tc>
+                  <a:txBody>
+                    <a:bodyPr wrap="square"/>
+                    <a:lstStyle/>
+                    <a:p>
+                      <a:r>
+                        <a:rPr sz="1100" b="0">
+                          <a:solidFill>
+                            <a:srgbClr val="222B33"/>
+                          </a:solidFill>
+                          <a:latin typeface="Segoe UI"/>
+                        </a:rPr>
+                        <a:t>Dual-mode: companion + legacy in one architecture</a:t>
+                      </a:r>
+                    </a:p>
+                  </a:txBody>
+                  <a:tcPr marL="73152" marR="54864" marT="18288" marB="18288" anchor="ctr">
+                    <a:solidFill>
+                      <a:srgbClr val="F2F8F7"/>
+                    </a:solidFill>
+                  </a:tcPr>
+                </a:tc>
+              </a:tr>
+            </a:tbl>
+          </a:graphicData>
+        </a:graphic>
+      </p:graphicFrame>
+      <p:sp>
+        <p:nvSpPr>
+          <p:cNvPr id="7" name="TextBox 6"/>
+          <p:cNvSpPr txBox="1"/>
+          <p:nvPr/>
+        </p:nvSpPr>
+        <p:spPr>
+          <a:xfrm>
+            <a:off x="548640" y="6419088"/>
+            <a:ext cx="8229600" cy="320040"/>
+          </a:xfrm>
+          <a:prstGeom prst="rect">
+            <a:avLst/>
+          </a:prstGeom>
+          <a:noFill/>
+        </p:spPr>
+        <p:txBody>
+          <a:bodyPr wrap="square" anchor="t" lIns="0" rIns="0" tIns="0" bIns="0">
+            <a:spAutoFit/>
+          </a:bodyPr>
+          <a:lstStyle/>
+          <a:p>
+            <a:pPr algn="l"/>
+            <a:r>
+              <a:rPr sz="900" b="0" i="0">
+                <a:solidFill>
+                  <a:srgbClr val="8A97A5"/>
+                </a:solidFill>
+                <a:latin typeface="Segoe UI"/>
+              </a:rPr>
+              <a:t>NinaivX  ·  Ashwin Kumar Ramesh Kumar  ·  MSc AI, University of Sheffield</a:t>
+            </a:r>
+          </a:p>
+        </p:txBody>
+      </p:sp>
+      <p:sp>
+        <p:nvSpPr>
+          <p:cNvPr id="8" name="TextBox 7"/>
+          <p:cNvSpPr txBox="1"/>
+          <p:nvPr/>
+        </p:nvSpPr>
+        <p:spPr>
+          <a:xfrm>
+            <a:off x="10972800" y="6419088"/>
+            <a:ext cx="822960" cy="320040"/>
+          </a:xfrm>
+          <a:prstGeom prst="rect">
+            <a:avLst/>
+          </a:prstGeom>
+          <a:noFill/>
+        </p:spPr>
+        <p:txBody>
+          <a:bodyPr wrap="square" anchor="t" lIns="0" rIns="0" tIns="0" bIns="0">
+            <a:spAutoFit/>
+          </a:bodyPr>
+          <a:lstStyle/>
+          <a:p>
+            <a:pPr algn="r"/>
+            <a:r>
+              <a:rPr sz="1000" b="1" i="0">
+                <a:solidFill>
+                  <a:srgbClr val="8A97A5"/>
+                </a:solidFill>
+                <a:latin typeface="Segoe UI"/>
+              </a:rPr>
+              <a:t>6</a:t>
             </a:r>
           </a:p>
         </p:txBody>

</xml_diff>

<commit_message>
Remove the backup gaps slide (deck back to 5 slides)
Co-Authored-By: Claude Opus 4.8 <noreply@anthropic.com>
Claude-Session: https://claude.ai/code/session_01NdSzTk1rMfZ8qJXjYpCNwm
</commit_message>
<xml_diff>
--- a/backend/docs/report/NinaivX-Presentation.pptx
+++ b/backend/docs/report/NinaivX-Presentation.pptx
@@ -10,7 +10,6 @@
     <p:sldId id="258" r:id="rId10"/>
     <p:sldId id="259" r:id="rId11"/>
     <p:sldId id="260" r:id="rId12"/>
-    <p:sldId id="261" r:id="rId13"/>
   </p:sldIdLst>
   <p:sldSz cx="12191695" cy="6858000" type="screen4x3"/>
   <p:notesSz cx="6858000" cy="9144000"/>
@@ -800,76 +799,6 @@
           <a:p>
             <a:r>
               <a:t>VIVA QUICK FACTS: Claude Sonnet on AWS Bedrock (EU); FastAPI+LangGraph, Supabase, ElevenLabs, React Native/Expo. Air-gap = deceased node binds no tools (code-level). Hallucination 83-&gt;25% overall, post-death 100-&gt;0% (declined every one). Study n=21, 4.6/5. Deterministic router so routing can't be manipulated. Ethics ref 076699. Main limitation: personal-fact confabulation -&gt; fix with RAG.</a:t>
-            </a:r>
-          </a:p>
-        </p:txBody>
-      </p:sp>
-      <p:sp>
-        <p:nvSpPr>
-          <p:cNvPr id="4" name="Slide Number Placeholder 3"/>
-          <p:cNvSpPr>
-            <a:spLocks noGrp="1"/>
-          </p:cNvSpPr>
-          <p:nvPr>
-            <p:ph type="sldNum" idx="5" sz="quarter"/>
-          </p:nvPr>
-        </p:nvSpPr>
-        <p:spPr/>
-      </p:sp>
-    </p:spTree>
-  </p:cSld>
-  <p:clrMapOvr>
-    <a:masterClrMapping/>
-  </p:clrMapOvr>
-</p:notes>
-</file>
-
-<file path=ppt/notesSlides/notesSlide6.xml><?xml version="1.0" encoding="utf-8"?>
-<p:notes xmlns:a="http://schemas.openxmlformats.org/drawingml/2006/main" xmlns:p="http://schemas.openxmlformats.org/presentationml/2006/main" xmlns:r="http://schemas.openxmlformats.org/officeDocument/2006/relationships">
-  <p:cSld>
-    <p:spTree>
-      <p:nvGrpSpPr>
-        <p:cNvPr id="1" name=""/>
-        <p:cNvGrpSpPr/>
-        <p:nvPr/>
-      </p:nvGrpSpPr>
-      <p:grpSpPr>
-        <a:xfrm>
-          <a:off x="0" y="0"/>
-          <a:ext cx="0" cy="0"/>
-          <a:chOff x="0" y="0"/>
-          <a:chExt cx="0" cy="0"/>
-        </a:xfrm>
-      </p:grpSpPr>
-      <p:sp>
-        <p:nvSpPr>
-          <p:cNvPr id="2" name="Slide Image Placeholder 1"/>
-          <p:cNvSpPr>
-            <a:spLocks noGrp="1"/>
-          </p:cNvSpPr>
-          <p:nvPr>
-            <p:ph type="sldImg" idx="2"/>
-          </p:nvPr>
-        </p:nvSpPr>
-        <p:spPr/>
-      </p:sp>
-      <p:sp>
-        <p:nvSpPr>
-          <p:cNvPr id="3" name="Notes Placeholder 2"/>
-          <p:cNvSpPr>
-            <a:spLocks noGrp="1"/>
-          </p:cNvSpPr>
-          <p:nvPr>
-            <p:ph type="body" idx="3" sz="quarter"/>
-          </p:nvPr>
-        </p:nvSpPr>
-        <p:spPr/>
-        <p:txBody>
-          <a:bodyPr/>
-          <a:lstStyle/>
-          <a:p>
-            <a:r>
-              <a:t>BACKUP SLIDE — do not present unless asked. If a marker asks 'how does this address the gaps you found?', show this. Key line: every gap is addressed — most by design/requirements, and the two open, testable ones (hallucination G3 and dual-mode G9) became my research questions RQ1 and RQ2.</a:t>
             </a:r>
           </a:p>
         </p:txBody>
@@ -6233,738 +6162,6 @@
                 <a:latin typeface="Segoe UI"/>
               </a:rPr>
               <a:t>5</a:t>
-            </a:r>
-          </a:p>
-        </p:txBody>
-      </p:sp>
-    </p:spTree>
-  </p:cSld>
-  <p:clrMapOvr>
-    <a:masterClrMapping/>
-  </p:clrMapOvr>
-</p:sld>
-</file>
-
-<file path=ppt/slides/slide6.xml><?xml version="1.0" encoding="utf-8"?>
-<p:sld xmlns:a="http://schemas.openxmlformats.org/drawingml/2006/main" xmlns:p="http://schemas.openxmlformats.org/presentationml/2006/main" xmlns:r="http://schemas.openxmlformats.org/officeDocument/2006/relationships">
-  <p:cSld>
-    <p:spTree>
-      <p:nvGrpSpPr>
-        <p:cNvPr id="1" name=""/>
-        <p:cNvGrpSpPr/>
-        <p:nvPr/>
-      </p:nvGrpSpPr>
-      <p:grpSpPr/>
-      <p:sp>
-        <p:nvSpPr>
-          <p:cNvPr id="2" name="Rectangle 1"/>
-          <p:cNvSpPr/>
-          <p:nvPr/>
-        </p:nvSpPr>
-        <p:spPr>
-          <a:xfrm>
-            <a:off x="0" y="0"/>
-            <a:ext cx="12191695" cy="146304"/>
-          </a:xfrm>
-          <a:prstGeom prst="rect">
-            <a:avLst/>
-          </a:prstGeom>
-          <a:solidFill>
-            <a:srgbClr val="2A6F6B"/>
-          </a:solidFill>
-          <a:ln>
-            <a:noFill/>
-          </a:ln>
-          <a:effectLst/>
-        </p:spPr>
-        <p:style>
-          <a:lnRef idx="1">
-            <a:schemeClr val="accent1"/>
-          </a:lnRef>
-          <a:fillRef idx="3">
-            <a:schemeClr val="accent1"/>
-          </a:fillRef>
-          <a:effectRef idx="2">
-            <a:schemeClr val="accent1"/>
-          </a:effectRef>
-          <a:fontRef idx="minor">
-            <a:schemeClr val="lt1"/>
-          </a:fontRef>
-        </p:style>
-        <p:txBody>
-          <a:bodyPr rtlCol="0" anchor="ctr"/>
-          <a:lstStyle/>
-          <a:p>
-            <a:pPr algn="ctr"/>
-          </a:p>
-        </p:txBody>
-      </p:sp>
-      <p:sp>
-        <p:nvSpPr>
-          <p:cNvPr id="3" name="TextBox 2"/>
-          <p:cNvSpPr txBox="1"/>
-          <p:nvPr/>
-        </p:nvSpPr>
-        <p:spPr>
-          <a:xfrm>
-            <a:off x="548640" y="384048"/>
-            <a:ext cx="11064240" cy="822960"/>
-          </a:xfrm>
-          <a:prstGeom prst="rect">
-            <a:avLst/>
-          </a:prstGeom>
-          <a:noFill/>
-        </p:spPr>
-        <p:txBody>
-          <a:bodyPr wrap="square" anchor="t" lIns="0" rIns="0" tIns="0" bIns="0">
-            <a:spAutoFit/>
-          </a:bodyPr>
-          <a:lstStyle/>
-          <a:p>
-            <a:pPr algn="l"/>
-            <a:r>
-              <a:rPr sz="3000" b="1" i="0">
-                <a:solidFill>
-                  <a:srgbClr val="2A6F6B"/>
-                </a:solidFill>
-                <a:latin typeface="Segoe UI"/>
-              </a:rPr>
-              <a:t>Research gaps → how NinaivX addresses them</a:t>
-            </a:r>
-          </a:p>
-        </p:txBody>
-      </p:sp>
-      <p:sp>
-        <p:nvSpPr>
-          <p:cNvPr id="4" name="Rectangle 3"/>
-          <p:cNvSpPr/>
-          <p:nvPr/>
-        </p:nvSpPr>
-        <p:spPr>
-          <a:xfrm>
-            <a:off x="566928" y="1170432"/>
-            <a:ext cx="2926080" cy="41148"/>
-          </a:xfrm>
-          <a:prstGeom prst="rect">
-            <a:avLst/>
-          </a:prstGeom>
-          <a:solidFill>
-            <a:srgbClr val="C97A1A"/>
-          </a:solidFill>
-          <a:ln>
-            <a:noFill/>
-          </a:ln>
-          <a:effectLst/>
-        </p:spPr>
-        <p:style>
-          <a:lnRef idx="1">
-            <a:schemeClr val="accent1"/>
-          </a:lnRef>
-          <a:fillRef idx="3">
-            <a:schemeClr val="accent1"/>
-          </a:fillRef>
-          <a:effectRef idx="2">
-            <a:schemeClr val="accent1"/>
-          </a:effectRef>
-          <a:fontRef idx="minor">
-            <a:schemeClr val="lt1"/>
-          </a:fontRef>
-        </p:style>
-        <p:txBody>
-          <a:bodyPr rtlCol="0" anchor="ctr"/>
-          <a:lstStyle/>
-          <a:p>
-            <a:pPr algn="ctr"/>
-          </a:p>
-        </p:txBody>
-      </p:sp>
-      <p:sp>
-        <p:nvSpPr>
-          <p:cNvPr id="5" name="TextBox 4"/>
-          <p:cNvSpPr txBox="1"/>
-          <p:nvPr/>
-        </p:nvSpPr>
-        <p:spPr>
-          <a:xfrm>
-            <a:off x="566928" y="1243584"/>
-            <a:ext cx="10972800" cy="457200"/>
-          </a:xfrm>
-          <a:prstGeom prst="rect">
-            <a:avLst/>
-          </a:prstGeom>
-          <a:noFill/>
-        </p:spPr>
-        <p:txBody>
-          <a:bodyPr wrap="square" anchor="t" lIns="0" rIns="0" tIns="0" bIns="0">
-            <a:spAutoFit/>
-          </a:bodyPr>
-          <a:lstStyle/>
-          <a:p>
-            <a:pPr algn="l"/>
-            <a:r>
-              <a:rPr sz="1500" b="0" i="1">
-                <a:solidFill>
-                  <a:srgbClr val="444E57"/>
-                </a:solidFill>
-                <a:latin typeface="Segoe UI"/>
-              </a:rPr>
-              <a:t>Backup slide — for questions</a:t>
-            </a:r>
-          </a:p>
-        </p:txBody>
-      </p:sp>
-      <p:graphicFrame>
-        <p:nvGraphicFramePr>
-          <p:cNvPr id="6" name="Table 5"/>
-          <p:cNvGraphicFramePr>
-            <a:graphicFrameLocks noGrp="1"/>
-          </p:cNvGraphicFramePr>
-          <p:nvPr/>
-        </p:nvGraphicFramePr>
-        <p:xfrm>
-          <a:off x="457200" y="1417320"/>
-          <a:ext cx="11274552" cy="4663440"/>
-        </p:xfrm>
-        <a:graphic>
-          <a:graphicData uri="http://schemas.openxmlformats.org/drawingml/2006/table">
-            <a:tbl>
-              <a:tblPr firstRow="1" bandRow="1">
-                <a:tableStyleId>{5C22544A-7EE6-4342-B048-85BDC9FD1C3A}</a:tableStyleId>
-              </a:tblPr>
-              <a:tblGrid>
-                <a:gridCol w="4937760"/>
-                <a:gridCol w="6336792"/>
-              </a:tblGrid>
-              <a:tr h="466344">
-                <a:tc>
-                  <a:txBody>
-                    <a:bodyPr wrap="square"/>
-                    <a:lstStyle/>
-                    <a:p>
-                      <a:r>
-                        <a:rPr sz="1200" b="1">
-                          <a:solidFill>
-                            <a:srgbClr val="FFFFFF"/>
-                          </a:solidFill>
-                          <a:latin typeface="Segoe UI"/>
-                        </a:rPr>
-                        <a:t>Gap in existing systems</a:t>
-                      </a:r>
-                    </a:p>
-                  </a:txBody>
-                  <a:tcPr marL="73152" marR="54864" marT="18288" marB="18288" anchor="ctr">
-                    <a:solidFill>
-                      <a:srgbClr val="2A6F6B"/>
-                    </a:solidFill>
-                  </a:tcPr>
-                </a:tc>
-                <a:tc>
-                  <a:txBody>
-                    <a:bodyPr wrap="square"/>
-                    <a:lstStyle/>
-                    <a:p>
-                      <a:r>
-                        <a:rPr sz="1200" b="1">
-                          <a:solidFill>
-                            <a:srgbClr val="FFFFFF"/>
-                          </a:solidFill>
-                          <a:latin typeface="Segoe UI"/>
-                        </a:rPr>
-                        <a:t>How NinaivX addresses it</a:t>
-                      </a:r>
-                    </a:p>
-                  </a:txBody>
-                  <a:tcPr marL="73152" marR="54864" marT="18288" marB="18288" anchor="ctr">
-                    <a:solidFill>
-                      <a:srgbClr val="2A6F6B"/>
-                    </a:solidFill>
-                  </a:tcPr>
-                </a:tc>
-              </a:tr>
-              <a:tr h="466344">
-                <a:tc>
-                  <a:txBody>
-                    <a:bodyPr wrap="square"/>
-                    <a:lstStyle/>
-                    <a:p>
-                      <a:r>
-                        <a:rPr sz="1100" b="1">
-                          <a:solidFill>
-                            <a:srgbClr val="222B33"/>
-                          </a:solidFill>
-                          <a:latin typeface="Segoe UI"/>
-                        </a:rPr>
-                        <a:t>G1  Static memorials only replay recordings — can’t converse</a:t>
-                      </a:r>
-                    </a:p>
-                  </a:txBody>
-                  <a:tcPr marL="73152" marR="54864" marT="18288" marB="18288" anchor="ctr">
-                    <a:solidFill>
-                      <a:srgbClr val="F2F8F7"/>
-                    </a:solidFill>
-                  </a:tcPr>
-                </a:tc>
-                <a:tc>
-                  <a:txBody>
-                    <a:bodyPr wrap="square"/>
-                    <a:lstStyle/>
-                    <a:p>
-                      <a:r>
-                        <a:rPr sz="1100" b="0">
-                          <a:solidFill>
-                            <a:srgbClr val="222B33"/>
-                          </a:solidFill>
-                          <a:latin typeface="Segoe UI"/>
-                        </a:rPr>
-                        <a:t>Generative conversation with persistent memory</a:t>
-                      </a:r>
-                    </a:p>
-                  </a:txBody>
-                  <a:tcPr marL="73152" marR="54864" marT="18288" marB="18288" anchor="ctr">
-                    <a:solidFill>
-                      <a:srgbClr val="F2F8F7"/>
-                    </a:solidFill>
-                  </a:tcPr>
-                </a:tc>
-              </a:tr>
-              <a:tr h="466344">
-                <a:tc>
-                  <a:txBody>
-                    <a:bodyPr wrap="square"/>
-                    <a:lstStyle/>
-                    <a:p>
-                      <a:r>
-                        <a:rPr sz="1100" b="1">
-                          <a:solidFill>
-                            <a:srgbClr val="222B33"/>
-                          </a:solidFill>
-                          <a:latin typeface="Segoe UI"/>
-                        </a:rPr>
-                        <a:t>G2  Griefbots are text-only, no natural voice</a:t>
-                      </a:r>
-                    </a:p>
-                  </a:txBody>
-                  <a:tcPr marL="73152" marR="54864" marT="18288" marB="18288" anchor="ctr">
-                    <a:solidFill>
-                      <a:srgbClr val="FFFFFF"/>
-                    </a:solidFill>
-                  </a:tcPr>
-                </a:tc>
-                <a:tc>
-                  <a:txBody>
-                    <a:bodyPr wrap="square"/>
-                    <a:lstStyle/>
-                    <a:p>
-                      <a:r>
-                        <a:rPr sz="1100" b="0">
-                          <a:solidFill>
-                            <a:srgbClr val="222B33"/>
-                          </a:solidFill>
-                          <a:latin typeface="Segoe UI"/>
-                        </a:rPr>
-                        <a:t>Full voice loop (speech → AI → speech) + cloning</a:t>
-                      </a:r>
-                    </a:p>
-                  </a:txBody>
-                  <a:tcPr marL="73152" marR="54864" marT="18288" marB="18288" anchor="ctr">
-                    <a:solidFill>
-                      <a:srgbClr val="FFFFFF"/>
-                    </a:solidFill>
-                  </a:tcPr>
-                </a:tc>
-              </a:tr>
-              <a:tr h="466344">
-                <a:tc>
-                  <a:txBody>
-                    <a:bodyPr wrap="square"/>
-                    <a:lstStyle/>
-                    <a:p>
-                      <a:r>
-                        <a:rPr sz="1100" b="1">
-                          <a:solidFill>
-                            <a:srgbClr val="222B33"/>
-                          </a:solidFill>
-                          <a:latin typeface="Segoe UI"/>
-                        </a:rPr>
-                        <a:t>G3  Models hallucinate about the real person</a:t>
-                      </a:r>
-                    </a:p>
-                  </a:txBody>
-                  <a:tcPr marL="73152" marR="54864" marT="18288" marB="18288" anchor="ctr">
-                    <a:solidFill>
-                      <a:srgbClr val="F2F8F7"/>
-                    </a:solidFill>
-                  </a:tcPr>
-                </a:tc>
-                <a:tc>
-                  <a:txBody>
-                    <a:bodyPr wrap="square"/>
-                    <a:lstStyle/>
-                    <a:p>
-                      <a:r>
-                        <a:rPr sz="1100" b="0">
-                          <a:solidFill>
-                            <a:srgbClr val="222B33"/>
-                          </a:solidFill>
-                          <a:latin typeface="Segoe UI"/>
-                        </a:rPr>
-                        <a:t>Air-gap + temporal grounding (83→25%; post-death 100→0%)</a:t>
-                      </a:r>
-                    </a:p>
-                  </a:txBody>
-                  <a:tcPr marL="73152" marR="54864" marT="18288" marB="18288" anchor="ctr">
-                    <a:solidFill>
-                      <a:srgbClr val="F2F8F7"/>
-                    </a:solidFill>
-                  </a:tcPr>
-                </a:tc>
-              </a:tr>
-              <a:tr h="466344">
-                <a:tc>
-                  <a:txBody>
-                    <a:bodyPr wrap="square"/>
-                    <a:lstStyle/>
-                    <a:p>
-                      <a:r>
-                        <a:rPr sz="1100" b="1">
-                          <a:solidFill>
-                            <a:srgbClr val="222B33"/>
-                          </a:solidFill>
-                          <a:latin typeface="Segoe UI"/>
-                        </a:rPr>
-                        <a:t>G4  No AI-transparency disclosure</a:t>
-                      </a:r>
-                    </a:p>
-                  </a:txBody>
-                  <a:tcPr marL="73152" marR="54864" marT="18288" marB="18288" anchor="ctr">
-                    <a:solidFill>
-                      <a:srgbClr val="FFFFFF"/>
-                    </a:solidFill>
-                  </a:tcPr>
-                </a:tc>
-                <a:tc>
-                  <a:txBody>
-                    <a:bodyPr wrap="square"/>
-                    <a:lstStyle/>
-                    <a:p>
-                      <a:r>
-                        <a:rPr sz="1100" b="0">
-                          <a:solidFill>
-                            <a:srgbClr val="222B33"/>
-                          </a:solidFill>
-                          <a:latin typeface="Segoe UI"/>
-                        </a:rPr>
-                        <a:t>Discloses it is an AI; notice each session</a:t>
-                      </a:r>
-                    </a:p>
-                  </a:txBody>
-                  <a:tcPr marL="73152" marR="54864" marT="18288" marB="18288" anchor="ctr">
-                    <a:solidFill>
-                      <a:srgbClr val="FFFFFF"/>
-                    </a:solidFill>
-                  </a:tcPr>
-                </a:tc>
-              </a:tr>
-              <a:tr h="466344">
-                <a:tc>
-                  <a:txBody>
-                    <a:bodyPr wrap="square"/>
-                    <a:lstStyle/>
-                    <a:p>
-                      <a:r>
-                        <a:rPr sz="1100" b="1">
-                          <a:solidFill>
-                            <a:srgbClr val="222B33"/>
-                          </a:solidFill>
-                          <a:latin typeface="Segoe UI"/>
-                        </a:rPr>
-                        <a:t>G5  Engagement-driven design fosters dependency</a:t>
-                      </a:r>
-                    </a:p>
-                  </a:txBody>
-                  <a:tcPr marL="73152" marR="54864" marT="18288" marB="18288" anchor="ctr">
-                    <a:solidFill>
-                      <a:srgbClr val="F2F8F7"/>
-                    </a:solidFill>
-                  </a:tcPr>
-                </a:tc>
-                <a:tc>
-                  <a:txBody>
-                    <a:bodyPr wrap="square"/>
-                    <a:lstStyle/>
-                    <a:p>
-                      <a:r>
-                        <a:rPr sz="1100" b="0">
-                          <a:solidFill>
-                            <a:srgbClr val="222B33"/>
-                          </a:solidFill>
-                          <a:latin typeface="Segoe UI"/>
-                        </a:rPr>
-                        <a:t>No gamification; designed for grief &amp; closure</a:t>
-                      </a:r>
-                    </a:p>
-                  </a:txBody>
-                  <a:tcPr marL="73152" marR="54864" marT="18288" marB="18288" anchor="ctr">
-                    <a:solidFill>
-                      <a:srgbClr val="F2F8F7"/>
-                    </a:solidFill>
-                  </a:tcPr>
-                </a:tc>
-              </a:tr>
-              <a:tr h="466344">
-                <a:tc>
-                  <a:txBody>
-                    <a:bodyPr wrap="square"/>
-                    <a:lstStyle/>
-                    <a:p>
-                      <a:r>
-                        <a:rPr sz="1100" b="1">
-                          <a:solidFill>
-                            <a:srgbClr val="222B33"/>
-                          </a:solidFill>
-                          <a:latin typeface="Segoe UI"/>
-                        </a:rPr>
-                        <a:t>G6  Sensitive data handled opaquely</a:t>
-                      </a:r>
-                    </a:p>
-                  </a:txBody>
-                  <a:tcPr marL="73152" marR="54864" marT="18288" marB="18288" anchor="ctr">
-                    <a:solidFill>
-                      <a:srgbClr val="FFFFFF"/>
-                    </a:solidFill>
-                  </a:tcPr>
-                </a:tc>
-                <a:tc>
-                  <a:txBody>
-                    <a:bodyPr wrap="square"/>
-                    <a:lstStyle/>
-                    <a:p>
-                      <a:r>
-                        <a:rPr sz="1100" b="0">
-                          <a:solidFill>
-                            <a:srgbClr val="222B33"/>
-                          </a:solidFill>
-                          <a:latin typeface="Segoe UI"/>
-                        </a:rPr>
-                        <a:t>Per-user isolation, auth, summary-only memory, synthetic voices</a:t>
-                      </a:r>
-                    </a:p>
-                  </a:txBody>
-                  <a:tcPr marL="73152" marR="54864" marT="18288" marB="18288" anchor="ctr">
-                    <a:solidFill>
-                      <a:srgbClr val="FFFFFF"/>
-                    </a:solidFill>
-                  </a:tcPr>
-                </a:tc>
-              </a:tr>
-              <a:tr h="466344">
-                <a:tc>
-                  <a:txBody>
-                    <a:bodyPr wrap="square"/>
-                    <a:lstStyle/>
-                    <a:p>
-                      <a:r>
-                        <a:rPr sz="1100" b="1">
-                          <a:solidFill>
-                            <a:srgbClr val="222B33"/>
-                          </a:solidFill>
-                          <a:latin typeface="Segoe UI"/>
-                        </a:rPr>
-                        <a:t>G7  Closed, proprietary; not reproducible</a:t>
-                      </a:r>
-                    </a:p>
-                  </a:txBody>
-                  <a:tcPr marL="73152" marR="54864" marT="18288" marB="18288" anchor="ctr">
-                    <a:solidFill>
-                      <a:srgbClr val="F2F8F7"/>
-                    </a:solidFill>
-                  </a:tcPr>
-                </a:tc>
-                <a:tc>
-                  <a:txBody>
-                    <a:bodyPr wrap="square"/>
-                    <a:lstStyle/>
-                    <a:p>
-                      <a:r>
-                        <a:rPr sz="1100" b="0">
-                          <a:solidFill>
-                            <a:srgbClr val="222B33"/>
-                          </a:solidFill>
-                          <a:latin typeface="Segoe UI"/>
-                        </a:rPr>
-                        <a:t>Openly documented, reproducible architecture</a:t>
-                      </a:r>
-                    </a:p>
-                  </a:txBody>
-                  <a:tcPr marL="73152" marR="54864" marT="18288" marB="18288" anchor="ctr">
-                    <a:solidFill>
-                      <a:srgbClr val="F2F8F7"/>
-                    </a:solidFill>
-                  </a:tcPr>
-                </a:tc>
-              </a:tr>
-              <a:tr h="466344">
-                <a:tc>
-                  <a:txBody>
-                    <a:bodyPr wrap="square"/>
-                    <a:lstStyle/>
-                    <a:p>
-                      <a:r>
-                        <a:rPr sz="1100" b="1">
-                          <a:solidFill>
-                            <a:srgbClr val="222B33"/>
-                          </a:solidFill>
-                          <a:latin typeface="Segoe UI"/>
-                        </a:rPr>
-                        <a:t>G8  No published evaluation</a:t>
-                      </a:r>
-                    </a:p>
-                  </a:txBody>
-                  <a:tcPr marL="73152" marR="54864" marT="18288" marB="18288" anchor="ctr">
-                    <a:solidFill>
-                      <a:srgbClr val="FFFFFF"/>
-                    </a:solidFill>
-                  </a:tcPr>
-                </a:tc>
-                <a:tc>
-                  <a:txBody>
-                    <a:bodyPr wrap="square"/>
-                    <a:lstStyle/>
-                    <a:p>
-                      <a:r>
-                        <a:rPr sz="1100" b="0">
-                          <a:solidFill>
-                            <a:srgbClr val="222B33"/>
-                          </a:solidFill>
-                          <a:latin typeface="Segoe UI"/>
-                        </a:rPr>
-                        <a:t>User study (n=21) + controlled hallucination experiment</a:t>
-                      </a:r>
-                    </a:p>
-                  </a:txBody>
-                  <a:tcPr marL="73152" marR="54864" marT="18288" marB="18288" anchor="ctr">
-                    <a:solidFill>
-                      <a:srgbClr val="FFFFFF"/>
-                    </a:solidFill>
-                  </a:tcPr>
-                </a:tc>
-              </a:tr>
-              <a:tr h="466344">
-                <a:tc>
-                  <a:txBody>
-                    <a:bodyPr wrap="square"/>
-                    <a:lstStyle/>
-                    <a:p>
-                      <a:r>
-                        <a:rPr sz="1100" b="1">
-                          <a:solidFill>
-                            <a:srgbClr val="222B33"/>
-                          </a:solidFill>
-                          <a:latin typeface="Segoe UI"/>
-                        </a:rPr>
-                        <a:t>G9  Deceased-only; no companion mode</a:t>
-                      </a:r>
-                    </a:p>
-                  </a:txBody>
-                  <a:tcPr marL="73152" marR="54864" marT="18288" marB="18288" anchor="ctr">
-                    <a:solidFill>
-                      <a:srgbClr val="F2F8F7"/>
-                    </a:solidFill>
-                  </a:tcPr>
-                </a:tc>
-                <a:tc>
-                  <a:txBody>
-                    <a:bodyPr wrap="square"/>
-                    <a:lstStyle/>
-                    <a:p>
-                      <a:r>
-                        <a:rPr sz="1100" b="0">
-                          <a:solidFill>
-                            <a:srgbClr val="222B33"/>
-                          </a:solidFill>
-                          <a:latin typeface="Segoe UI"/>
-                        </a:rPr>
-                        <a:t>Dual-mode: companion + legacy in one architecture</a:t>
-                      </a:r>
-                    </a:p>
-                  </a:txBody>
-                  <a:tcPr marL="73152" marR="54864" marT="18288" marB="18288" anchor="ctr">
-                    <a:solidFill>
-                      <a:srgbClr val="F2F8F7"/>
-                    </a:solidFill>
-                  </a:tcPr>
-                </a:tc>
-              </a:tr>
-            </a:tbl>
-          </a:graphicData>
-        </a:graphic>
-      </p:graphicFrame>
-      <p:sp>
-        <p:nvSpPr>
-          <p:cNvPr id="7" name="TextBox 6"/>
-          <p:cNvSpPr txBox="1"/>
-          <p:nvPr/>
-        </p:nvSpPr>
-        <p:spPr>
-          <a:xfrm>
-            <a:off x="548640" y="6419088"/>
-            <a:ext cx="8229600" cy="320040"/>
-          </a:xfrm>
-          <a:prstGeom prst="rect">
-            <a:avLst/>
-          </a:prstGeom>
-          <a:noFill/>
-        </p:spPr>
-        <p:txBody>
-          <a:bodyPr wrap="square" anchor="t" lIns="0" rIns="0" tIns="0" bIns="0">
-            <a:spAutoFit/>
-          </a:bodyPr>
-          <a:lstStyle/>
-          <a:p>
-            <a:pPr algn="l"/>
-            <a:r>
-              <a:rPr sz="900" b="0" i="0">
-                <a:solidFill>
-                  <a:srgbClr val="8A97A5"/>
-                </a:solidFill>
-                <a:latin typeface="Segoe UI"/>
-              </a:rPr>
-              <a:t>NinaivX  ·  Ashwin Kumar Ramesh Kumar  ·  MSc AI, University of Sheffield</a:t>
-            </a:r>
-          </a:p>
-        </p:txBody>
-      </p:sp>
-      <p:sp>
-        <p:nvSpPr>
-          <p:cNvPr id="8" name="TextBox 7"/>
-          <p:cNvSpPr txBox="1"/>
-          <p:nvPr/>
-        </p:nvSpPr>
-        <p:spPr>
-          <a:xfrm>
-            <a:off x="10972800" y="6419088"/>
-            <a:ext cx="822960" cy="320040"/>
-          </a:xfrm>
-          <a:prstGeom prst="rect">
-            <a:avLst/>
-          </a:prstGeom>
-          <a:noFill/>
-        </p:spPr>
-        <p:txBody>
-          <a:bodyPr wrap="square" anchor="t" lIns="0" rIns="0" tIns="0" bIns="0">
-            <a:spAutoFit/>
-          </a:bodyPr>
-          <a:lstStyle/>
-          <a:p>
-            <a:pPr algn="r"/>
-            <a:r>
-              <a:rPr sz="1000" b="1" i="0">
-                <a:solidFill>
-                  <a:srgbClr val="8A97A5"/>
-                </a:solidFill>
-                <a:latin typeface="Segoe UI"/>
-              </a:rPr>
-              <a:t>6</a:t>
             </a:r>
           </a:p>
         </p:txBody>

</xml_diff>